<commit_message>
fix(plano-b): troca conectores por retangulos (corrige reparo do PowerPoint)
</commit_message>
<xml_diff>
--- a/plano_b_pso_diabetes/Apresentacao_Equipe4_PlanoB.pptx
+++ b/plano_b_pso_diabetes/Apresentacao_Equipe4_PlanoB.pptx
@@ -3292,42 +3292,50 @@
           </a:p>
         </p:txBody>
       </p:sp>
-      <p:cxnSp>
-        <p:nvCxnSpPr>
-          <p:cNvPr id="6" name="Connector 5"/>
-          <p:cNvCxnSpPr/>
-          <p:nvPr/>
-        </p:nvCxnSpPr>
-        <p:spPr>
-          <a:xfrm>
-            <a:off x="841248" y="3611880"/>
-            <a:ext cx="3840480" cy="0"/>
-          </a:xfrm>
-          <a:prstGeom prst="bentConnector3">
-            <a:avLst/>
-          </a:prstGeom>
-          <a:ln w="25400">
-            <a:solidFill>
-              <a:srgbClr val="1F4E5F"/>
-            </a:solidFill>
+      <p:sp>
+        <p:nvSpPr>
+          <p:cNvPr id="6" name="Rectangle 5"/>
+          <p:cNvSpPr/>
+          <p:nvPr/>
+        </p:nvSpPr>
+        <p:spPr>
+          <a:xfrm>
+            <a:off x="841248" y="3599180"/>
+            <a:ext cx="3840480" cy="25400"/>
+          </a:xfrm>
+          <a:prstGeom prst="rect">
+            <a:avLst/>
+          </a:prstGeom>
+          <a:solidFill>
+            <a:srgbClr val="1F4E5F"/>
+          </a:solidFill>
+          <a:ln>
+            <a:noFill/>
           </a:ln>
           <a:effectLst/>
         </p:spPr>
         <p:style>
-          <a:lnRef idx="2">
+          <a:lnRef idx="1">
             <a:schemeClr val="accent1"/>
           </a:lnRef>
-          <a:fillRef idx="0">
+          <a:fillRef idx="3">
             <a:schemeClr val="accent1"/>
           </a:fillRef>
-          <a:effectRef idx="1">
+          <a:effectRef idx="2">
             <a:schemeClr val="accent1"/>
           </a:effectRef>
           <a:fontRef idx="minor">
-            <a:schemeClr val="tx1"/>
+            <a:schemeClr val="lt1"/>
           </a:fontRef>
         </p:style>
-      </p:cxnSp>
+        <p:txBody>
+          <a:bodyPr rtlCol="0" anchor="ctr"/>
+          <a:lstStyle/>
+          <a:p>
+            <a:pPr algn="ctr"/>
+          </a:p>
+        </p:txBody>
+      </p:sp>
       <p:sp>
         <p:nvSpPr>
           <p:cNvPr id="7" name="TextBox 6"/>
@@ -3577,42 +3585,50 @@
           </a:p>
         </p:txBody>
       </p:sp>
-      <p:cxnSp>
-        <p:nvCxnSpPr>
-          <p:cNvPr id="5" name="Connector 4"/>
-          <p:cNvCxnSpPr/>
-          <p:nvPr/>
-        </p:nvCxnSpPr>
-        <p:spPr>
-          <a:xfrm>
-            <a:off x="841248" y="1389888"/>
-            <a:ext cx="10509199" cy="0"/>
-          </a:xfrm>
-          <a:prstGeom prst="bentConnector3">
-            <a:avLst/>
-          </a:prstGeom>
-          <a:ln w="19050">
-            <a:solidFill>
-              <a:srgbClr val="1F4E5F"/>
-            </a:solidFill>
+      <p:sp>
+        <p:nvSpPr>
+          <p:cNvPr id="5" name="Rectangle 4"/>
+          <p:cNvSpPr/>
+          <p:nvPr/>
+        </p:nvSpPr>
+        <p:spPr>
+          <a:xfrm>
+            <a:off x="841248" y="1380363"/>
+            <a:ext cx="10509199" cy="19050"/>
+          </a:xfrm>
+          <a:prstGeom prst="rect">
+            <a:avLst/>
+          </a:prstGeom>
+          <a:solidFill>
+            <a:srgbClr val="1F4E5F"/>
+          </a:solidFill>
+          <a:ln>
+            <a:noFill/>
           </a:ln>
           <a:effectLst/>
         </p:spPr>
         <p:style>
-          <a:lnRef idx="2">
+          <a:lnRef idx="1">
             <a:schemeClr val="accent1"/>
           </a:lnRef>
-          <a:fillRef idx="0">
+          <a:fillRef idx="3">
             <a:schemeClr val="accent1"/>
           </a:fillRef>
-          <a:effectRef idx="1">
+          <a:effectRef idx="2">
             <a:schemeClr val="accent1"/>
           </a:effectRef>
           <a:fontRef idx="minor">
-            <a:schemeClr val="tx1"/>
+            <a:schemeClr val="lt1"/>
           </a:fontRef>
         </p:style>
-      </p:cxnSp>
+        <p:txBody>
+          <a:bodyPr rtlCol="0" anchor="ctr"/>
+          <a:lstStyle/>
+          <a:p>
+            <a:pPr algn="ctr"/>
+          </a:p>
+        </p:txBody>
+      </p:sp>
       <p:sp>
         <p:nvSpPr>
           <p:cNvPr id="6" name="TextBox 5"/>
@@ -4450,42 +4466,50 @@
           </a:p>
         </p:txBody>
       </p:sp>
-      <p:cxnSp>
-        <p:nvCxnSpPr>
-          <p:cNvPr id="5" name="Connector 4"/>
-          <p:cNvCxnSpPr/>
-          <p:nvPr/>
-        </p:nvCxnSpPr>
-        <p:spPr>
-          <a:xfrm>
-            <a:off x="841248" y="1389888"/>
-            <a:ext cx="10509199" cy="0"/>
-          </a:xfrm>
-          <a:prstGeom prst="bentConnector3">
-            <a:avLst/>
-          </a:prstGeom>
-          <a:ln w="19050">
-            <a:solidFill>
-              <a:srgbClr val="1F4E5F"/>
-            </a:solidFill>
+      <p:sp>
+        <p:nvSpPr>
+          <p:cNvPr id="5" name="Rectangle 4"/>
+          <p:cNvSpPr/>
+          <p:nvPr/>
+        </p:nvSpPr>
+        <p:spPr>
+          <a:xfrm>
+            <a:off x="841248" y="1380363"/>
+            <a:ext cx="10509199" cy="19050"/>
+          </a:xfrm>
+          <a:prstGeom prst="rect">
+            <a:avLst/>
+          </a:prstGeom>
+          <a:solidFill>
+            <a:srgbClr val="1F4E5F"/>
+          </a:solidFill>
+          <a:ln>
+            <a:noFill/>
           </a:ln>
           <a:effectLst/>
         </p:spPr>
         <p:style>
-          <a:lnRef idx="2">
+          <a:lnRef idx="1">
             <a:schemeClr val="accent1"/>
           </a:lnRef>
-          <a:fillRef idx="0">
+          <a:fillRef idx="3">
             <a:schemeClr val="accent1"/>
           </a:fillRef>
-          <a:effectRef idx="1">
+          <a:effectRef idx="2">
             <a:schemeClr val="accent1"/>
           </a:effectRef>
           <a:fontRef idx="minor">
-            <a:schemeClr val="tx1"/>
+            <a:schemeClr val="lt1"/>
           </a:fontRef>
         </p:style>
-      </p:cxnSp>
+        <p:txBody>
+          <a:bodyPr rtlCol="0" anchor="ctr"/>
+          <a:lstStyle/>
+          <a:p>
+            <a:pPr algn="ctr"/>
+          </a:p>
+        </p:txBody>
+      </p:sp>
       <p:sp>
         <p:nvSpPr>
           <p:cNvPr id="6" name="TextBox 5"/>
@@ -5070,42 +5094,50 @@
           </a:p>
         </p:txBody>
       </p:sp>
-      <p:cxnSp>
-        <p:nvCxnSpPr>
-          <p:cNvPr id="5" name="Connector 4"/>
-          <p:cNvCxnSpPr/>
-          <p:nvPr/>
-        </p:nvCxnSpPr>
-        <p:spPr>
-          <a:xfrm>
-            <a:off x="841248" y="1389888"/>
-            <a:ext cx="10509199" cy="0"/>
-          </a:xfrm>
-          <a:prstGeom prst="bentConnector3">
-            <a:avLst/>
-          </a:prstGeom>
-          <a:ln w="19050">
-            <a:solidFill>
-              <a:srgbClr val="1F4E5F"/>
-            </a:solidFill>
+      <p:sp>
+        <p:nvSpPr>
+          <p:cNvPr id="5" name="Rectangle 4"/>
+          <p:cNvSpPr/>
+          <p:nvPr/>
+        </p:nvSpPr>
+        <p:spPr>
+          <a:xfrm>
+            <a:off x="841248" y="1380363"/>
+            <a:ext cx="10509199" cy="19050"/>
+          </a:xfrm>
+          <a:prstGeom prst="rect">
+            <a:avLst/>
+          </a:prstGeom>
+          <a:solidFill>
+            <a:srgbClr val="1F4E5F"/>
+          </a:solidFill>
+          <a:ln>
+            <a:noFill/>
           </a:ln>
           <a:effectLst/>
         </p:spPr>
         <p:style>
-          <a:lnRef idx="2">
+          <a:lnRef idx="1">
             <a:schemeClr val="accent1"/>
           </a:lnRef>
-          <a:fillRef idx="0">
+          <a:fillRef idx="3">
             <a:schemeClr val="accent1"/>
           </a:fillRef>
-          <a:effectRef idx="1">
+          <a:effectRef idx="2">
             <a:schemeClr val="accent1"/>
           </a:effectRef>
           <a:fontRef idx="minor">
-            <a:schemeClr val="tx1"/>
+            <a:schemeClr val="lt1"/>
           </a:fontRef>
         </p:style>
-      </p:cxnSp>
+        <p:txBody>
+          <a:bodyPr rtlCol="0" anchor="ctr"/>
+          <a:lstStyle/>
+          <a:p>
+            <a:pPr algn="ctr"/>
+          </a:p>
+        </p:txBody>
+      </p:sp>
       <p:sp>
         <p:nvSpPr>
           <p:cNvPr id="6" name="TextBox 5"/>
@@ -5641,42 +5673,50 @@
           </a:p>
         </p:txBody>
       </p:sp>
-      <p:cxnSp>
-        <p:nvCxnSpPr>
-          <p:cNvPr id="5" name="Connector 4"/>
-          <p:cNvCxnSpPr/>
-          <p:nvPr/>
-        </p:nvCxnSpPr>
-        <p:spPr>
-          <a:xfrm>
-            <a:off x="841248" y="1389888"/>
-            <a:ext cx="10509199" cy="0"/>
-          </a:xfrm>
-          <a:prstGeom prst="bentConnector3">
-            <a:avLst/>
-          </a:prstGeom>
-          <a:ln w="19050">
-            <a:solidFill>
-              <a:srgbClr val="1F4E5F"/>
-            </a:solidFill>
+      <p:sp>
+        <p:nvSpPr>
+          <p:cNvPr id="5" name="Rectangle 4"/>
+          <p:cNvSpPr/>
+          <p:nvPr/>
+        </p:nvSpPr>
+        <p:spPr>
+          <a:xfrm>
+            <a:off x="841248" y="1380363"/>
+            <a:ext cx="10509199" cy="19050"/>
+          </a:xfrm>
+          <a:prstGeom prst="rect">
+            <a:avLst/>
+          </a:prstGeom>
+          <a:solidFill>
+            <a:srgbClr val="1F4E5F"/>
+          </a:solidFill>
+          <a:ln>
+            <a:noFill/>
           </a:ln>
           <a:effectLst/>
         </p:spPr>
         <p:style>
-          <a:lnRef idx="2">
+          <a:lnRef idx="1">
             <a:schemeClr val="accent1"/>
           </a:lnRef>
-          <a:fillRef idx="0">
+          <a:fillRef idx="3">
             <a:schemeClr val="accent1"/>
           </a:fillRef>
-          <a:effectRef idx="1">
+          <a:effectRef idx="2">
             <a:schemeClr val="accent1"/>
           </a:effectRef>
           <a:fontRef idx="minor">
-            <a:schemeClr val="tx1"/>
+            <a:schemeClr val="lt1"/>
           </a:fontRef>
         </p:style>
-      </p:cxnSp>
+        <p:txBody>
+          <a:bodyPr rtlCol="0" anchor="ctr"/>
+          <a:lstStyle/>
+          <a:p>
+            <a:pPr algn="ctr"/>
+          </a:p>
+        </p:txBody>
+      </p:sp>
       <p:sp>
         <p:nvSpPr>
           <p:cNvPr id="6" name="TextBox 5"/>
@@ -6699,42 +6739,50 @@
           </a:p>
         </p:txBody>
       </p:sp>
-      <p:cxnSp>
-        <p:nvCxnSpPr>
-          <p:cNvPr id="5" name="Connector 4"/>
-          <p:cNvCxnSpPr/>
-          <p:nvPr/>
-        </p:nvCxnSpPr>
-        <p:spPr>
-          <a:xfrm>
-            <a:off x="841248" y="1389888"/>
-            <a:ext cx="10509199" cy="0"/>
-          </a:xfrm>
-          <a:prstGeom prst="bentConnector3">
-            <a:avLst/>
-          </a:prstGeom>
-          <a:ln w="19050">
-            <a:solidFill>
-              <a:srgbClr val="1F4E5F"/>
-            </a:solidFill>
+      <p:sp>
+        <p:nvSpPr>
+          <p:cNvPr id="5" name="Rectangle 4"/>
+          <p:cNvSpPr/>
+          <p:nvPr/>
+        </p:nvSpPr>
+        <p:spPr>
+          <a:xfrm>
+            <a:off x="841248" y="1380363"/>
+            <a:ext cx="10509199" cy="19050"/>
+          </a:xfrm>
+          <a:prstGeom prst="rect">
+            <a:avLst/>
+          </a:prstGeom>
+          <a:solidFill>
+            <a:srgbClr val="1F4E5F"/>
+          </a:solidFill>
+          <a:ln>
+            <a:noFill/>
           </a:ln>
           <a:effectLst/>
         </p:spPr>
         <p:style>
-          <a:lnRef idx="2">
+          <a:lnRef idx="1">
             <a:schemeClr val="accent1"/>
           </a:lnRef>
-          <a:fillRef idx="0">
+          <a:fillRef idx="3">
             <a:schemeClr val="accent1"/>
           </a:fillRef>
-          <a:effectRef idx="1">
+          <a:effectRef idx="2">
             <a:schemeClr val="accent1"/>
           </a:effectRef>
           <a:fontRef idx="minor">
-            <a:schemeClr val="tx1"/>
+            <a:schemeClr val="lt1"/>
           </a:fontRef>
         </p:style>
-      </p:cxnSp>
+        <p:txBody>
+          <a:bodyPr rtlCol="0" anchor="ctr"/>
+          <a:lstStyle/>
+          <a:p>
+            <a:pPr algn="ctr"/>
+          </a:p>
+        </p:txBody>
+      </p:sp>
       <p:sp>
         <p:nvSpPr>
           <p:cNvPr id="6" name="TextBox 5"/>
@@ -7609,42 +7657,50 @@
           </a:p>
         </p:txBody>
       </p:sp>
-      <p:cxnSp>
-        <p:nvCxnSpPr>
-          <p:cNvPr id="5" name="Connector 4"/>
-          <p:cNvCxnSpPr/>
-          <p:nvPr/>
-        </p:nvCxnSpPr>
-        <p:spPr>
-          <a:xfrm>
-            <a:off x="841248" y="1389888"/>
-            <a:ext cx="10509199" cy="0"/>
-          </a:xfrm>
-          <a:prstGeom prst="bentConnector3">
-            <a:avLst/>
-          </a:prstGeom>
-          <a:ln w="19050">
-            <a:solidFill>
-              <a:srgbClr val="1F4E5F"/>
-            </a:solidFill>
+      <p:sp>
+        <p:nvSpPr>
+          <p:cNvPr id="5" name="Rectangle 4"/>
+          <p:cNvSpPr/>
+          <p:nvPr/>
+        </p:nvSpPr>
+        <p:spPr>
+          <a:xfrm>
+            <a:off x="841248" y="1380363"/>
+            <a:ext cx="10509199" cy="19050"/>
+          </a:xfrm>
+          <a:prstGeom prst="rect">
+            <a:avLst/>
+          </a:prstGeom>
+          <a:solidFill>
+            <a:srgbClr val="1F4E5F"/>
+          </a:solidFill>
+          <a:ln>
+            <a:noFill/>
           </a:ln>
           <a:effectLst/>
         </p:spPr>
         <p:style>
-          <a:lnRef idx="2">
+          <a:lnRef idx="1">
             <a:schemeClr val="accent1"/>
           </a:lnRef>
-          <a:fillRef idx="0">
+          <a:fillRef idx="3">
             <a:schemeClr val="accent1"/>
           </a:fillRef>
-          <a:effectRef idx="1">
+          <a:effectRef idx="2">
             <a:schemeClr val="accent1"/>
           </a:effectRef>
           <a:fontRef idx="minor">
-            <a:schemeClr val="tx1"/>
+            <a:schemeClr val="lt1"/>
           </a:fontRef>
         </p:style>
-      </p:cxnSp>
+        <p:txBody>
+          <a:bodyPr rtlCol="0" anchor="ctr"/>
+          <a:lstStyle/>
+          <a:p>
+            <a:pPr algn="ctr"/>
+          </a:p>
+        </p:txBody>
+      </p:sp>
       <p:sp>
         <p:nvSpPr>
           <p:cNvPr id="6" name="TextBox 5"/>
@@ -8752,42 +8808,50 @@
           </a:p>
         </p:txBody>
       </p:sp>
-      <p:cxnSp>
-        <p:nvCxnSpPr>
-          <p:cNvPr id="5" name="Connector 4"/>
-          <p:cNvCxnSpPr/>
-          <p:nvPr/>
-        </p:nvCxnSpPr>
-        <p:spPr>
-          <a:xfrm>
-            <a:off x="841248" y="1389888"/>
-            <a:ext cx="10509199" cy="0"/>
-          </a:xfrm>
-          <a:prstGeom prst="bentConnector3">
-            <a:avLst/>
-          </a:prstGeom>
-          <a:ln w="19050">
-            <a:solidFill>
-              <a:srgbClr val="1F4E5F"/>
-            </a:solidFill>
+      <p:sp>
+        <p:nvSpPr>
+          <p:cNvPr id="5" name="Rectangle 4"/>
+          <p:cNvSpPr/>
+          <p:nvPr/>
+        </p:nvSpPr>
+        <p:spPr>
+          <a:xfrm>
+            <a:off x="841248" y="1380363"/>
+            <a:ext cx="10509199" cy="19050"/>
+          </a:xfrm>
+          <a:prstGeom prst="rect">
+            <a:avLst/>
+          </a:prstGeom>
+          <a:solidFill>
+            <a:srgbClr val="1F4E5F"/>
+          </a:solidFill>
+          <a:ln>
+            <a:noFill/>
           </a:ln>
           <a:effectLst/>
         </p:spPr>
         <p:style>
-          <a:lnRef idx="2">
+          <a:lnRef idx="1">
             <a:schemeClr val="accent1"/>
           </a:lnRef>
-          <a:fillRef idx="0">
+          <a:fillRef idx="3">
             <a:schemeClr val="accent1"/>
           </a:fillRef>
-          <a:effectRef idx="1">
+          <a:effectRef idx="2">
             <a:schemeClr val="accent1"/>
           </a:effectRef>
           <a:fontRef idx="minor">
-            <a:schemeClr val="tx1"/>
+            <a:schemeClr val="lt1"/>
           </a:fontRef>
         </p:style>
-      </p:cxnSp>
+        <p:txBody>
+          <a:bodyPr rtlCol="0" anchor="ctr"/>
+          <a:lstStyle/>
+          <a:p>
+            <a:pPr algn="ctr"/>
+          </a:p>
+        </p:txBody>
+      </p:sp>
       <p:sp>
         <p:nvSpPr>
           <p:cNvPr id="6" name="TextBox 5"/>
@@ -9664,42 +9728,50 @@
           </a:p>
         </p:txBody>
       </p:sp>
-      <p:cxnSp>
-        <p:nvCxnSpPr>
-          <p:cNvPr id="5" name="Connector 4"/>
-          <p:cNvCxnSpPr/>
-          <p:nvPr/>
-        </p:nvCxnSpPr>
-        <p:spPr>
-          <a:xfrm>
-            <a:off x="841248" y="1389888"/>
-            <a:ext cx="10509199" cy="0"/>
-          </a:xfrm>
-          <a:prstGeom prst="bentConnector3">
-            <a:avLst/>
-          </a:prstGeom>
-          <a:ln w="19050">
-            <a:solidFill>
-              <a:srgbClr val="1F4E5F"/>
-            </a:solidFill>
+      <p:sp>
+        <p:nvSpPr>
+          <p:cNvPr id="5" name="Rectangle 4"/>
+          <p:cNvSpPr/>
+          <p:nvPr/>
+        </p:nvSpPr>
+        <p:spPr>
+          <a:xfrm>
+            <a:off x="841248" y="1380363"/>
+            <a:ext cx="10509199" cy="19050"/>
+          </a:xfrm>
+          <a:prstGeom prst="rect">
+            <a:avLst/>
+          </a:prstGeom>
+          <a:solidFill>
+            <a:srgbClr val="1F4E5F"/>
+          </a:solidFill>
+          <a:ln>
+            <a:noFill/>
           </a:ln>
           <a:effectLst/>
         </p:spPr>
         <p:style>
-          <a:lnRef idx="2">
+          <a:lnRef idx="1">
             <a:schemeClr val="accent1"/>
           </a:lnRef>
-          <a:fillRef idx="0">
+          <a:fillRef idx="3">
             <a:schemeClr val="accent1"/>
           </a:fillRef>
-          <a:effectRef idx="1">
+          <a:effectRef idx="2">
             <a:schemeClr val="accent1"/>
           </a:effectRef>
           <a:fontRef idx="minor">
-            <a:schemeClr val="tx1"/>
+            <a:schemeClr val="lt1"/>
           </a:fontRef>
         </p:style>
-      </p:cxnSp>
+        <p:txBody>
+          <a:bodyPr rtlCol="0" anchor="ctr"/>
+          <a:lstStyle/>
+          <a:p>
+            <a:pPr algn="ctr"/>
+          </a:p>
+        </p:txBody>
+      </p:sp>
       <p:sp>
         <p:nvSpPr>
           <p:cNvPr id="6" name="TextBox 5"/>
@@ -9826,42 +9898,50 @@
           </a:p>
         </p:txBody>
       </p:sp>
-      <p:cxnSp>
-        <p:nvCxnSpPr>
-          <p:cNvPr id="9" name="Connector 8"/>
-          <p:cNvCxnSpPr/>
-          <p:nvPr/>
-        </p:nvCxnSpPr>
-        <p:spPr>
-          <a:xfrm>
-            <a:off x="1115568" y="2148840"/>
-            <a:ext cx="9960559" cy="0"/>
-          </a:xfrm>
-          <a:prstGeom prst="bentConnector3">
-            <a:avLst/>
-          </a:prstGeom>
-          <a:ln w="25400">
-            <a:solidFill>
-              <a:srgbClr val="D9DEE0"/>
-            </a:solidFill>
+      <p:sp>
+        <p:nvSpPr>
+          <p:cNvPr id="9" name="Rectangle 8"/>
+          <p:cNvSpPr/>
+          <p:nvPr/>
+        </p:nvSpPr>
+        <p:spPr>
+          <a:xfrm>
+            <a:off x="1115568" y="2136140"/>
+            <a:ext cx="9960559" cy="25400"/>
+          </a:xfrm>
+          <a:prstGeom prst="rect">
+            <a:avLst/>
+          </a:prstGeom>
+          <a:solidFill>
+            <a:srgbClr val="D9DEE0"/>
+          </a:solidFill>
+          <a:ln>
+            <a:noFill/>
           </a:ln>
           <a:effectLst/>
         </p:spPr>
         <p:style>
-          <a:lnRef idx="2">
+          <a:lnRef idx="1">
             <a:schemeClr val="accent1"/>
           </a:lnRef>
-          <a:fillRef idx="0">
+          <a:fillRef idx="3">
             <a:schemeClr val="accent1"/>
           </a:fillRef>
-          <a:effectRef idx="1">
+          <a:effectRef idx="2">
             <a:schemeClr val="accent1"/>
           </a:effectRef>
           <a:fontRef idx="minor">
-            <a:schemeClr val="tx1"/>
+            <a:schemeClr val="lt1"/>
           </a:fontRef>
         </p:style>
-      </p:cxnSp>
+        <p:txBody>
+          <a:bodyPr rtlCol="0" anchor="ctr"/>
+          <a:lstStyle/>
+          <a:p>
+            <a:pPr algn="ctr"/>
+          </a:p>
+        </p:txBody>
+      </p:sp>
       <p:sp>
         <p:nvSpPr>
           <p:cNvPr id="10" name="Oval 9"/>
@@ -10872,42 +10952,50 @@
           </a:p>
         </p:txBody>
       </p:sp>
-      <p:cxnSp>
-        <p:nvCxnSpPr>
-          <p:cNvPr id="5" name="Connector 4"/>
-          <p:cNvCxnSpPr/>
-          <p:nvPr/>
-        </p:nvCxnSpPr>
-        <p:spPr>
-          <a:xfrm>
-            <a:off x="841248" y="1389888"/>
-            <a:ext cx="10509199" cy="0"/>
-          </a:xfrm>
-          <a:prstGeom prst="bentConnector3">
-            <a:avLst/>
-          </a:prstGeom>
-          <a:ln w="19050">
-            <a:solidFill>
-              <a:srgbClr val="1F4E5F"/>
-            </a:solidFill>
+      <p:sp>
+        <p:nvSpPr>
+          <p:cNvPr id="5" name="Rectangle 4"/>
+          <p:cNvSpPr/>
+          <p:nvPr/>
+        </p:nvSpPr>
+        <p:spPr>
+          <a:xfrm>
+            <a:off x="841248" y="1380363"/>
+            <a:ext cx="10509199" cy="19050"/>
+          </a:xfrm>
+          <a:prstGeom prst="rect">
+            <a:avLst/>
+          </a:prstGeom>
+          <a:solidFill>
+            <a:srgbClr val="1F4E5F"/>
+          </a:solidFill>
+          <a:ln>
+            <a:noFill/>
           </a:ln>
           <a:effectLst/>
         </p:spPr>
         <p:style>
-          <a:lnRef idx="2">
+          <a:lnRef idx="1">
             <a:schemeClr val="accent1"/>
           </a:lnRef>
-          <a:fillRef idx="0">
+          <a:fillRef idx="3">
             <a:schemeClr val="accent1"/>
           </a:fillRef>
-          <a:effectRef idx="1">
+          <a:effectRef idx="2">
             <a:schemeClr val="accent1"/>
           </a:effectRef>
           <a:fontRef idx="minor">
-            <a:schemeClr val="tx1"/>
+            <a:schemeClr val="lt1"/>
           </a:fontRef>
         </p:style>
-      </p:cxnSp>
+        <p:txBody>
+          <a:bodyPr rtlCol="0" anchor="ctr"/>
+          <a:lstStyle/>
+          <a:p>
+            <a:pPr algn="ctr"/>
+          </a:p>
+        </p:txBody>
+      </p:sp>
       <p:sp>
         <p:nvSpPr>
           <p:cNvPr id="6" name="TextBox 5"/>
@@ -12664,42 +12752,50 @@
           </a:p>
         </p:txBody>
       </p:sp>
-      <p:cxnSp>
-        <p:nvCxnSpPr>
-          <p:cNvPr id="5" name="Connector 4"/>
-          <p:cNvCxnSpPr/>
-          <p:nvPr/>
-        </p:nvCxnSpPr>
-        <p:spPr>
-          <a:xfrm>
-            <a:off x="841248" y="1389888"/>
-            <a:ext cx="10509199" cy="0"/>
-          </a:xfrm>
-          <a:prstGeom prst="bentConnector3">
-            <a:avLst/>
-          </a:prstGeom>
-          <a:ln w="19050">
-            <a:solidFill>
-              <a:srgbClr val="1F4E5F"/>
-            </a:solidFill>
+      <p:sp>
+        <p:nvSpPr>
+          <p:cNvPr id="5" name="Rectangle 4"/>
+          <p:cNvSpPr/>
+          <p:nvPr/>
+        </p:nvSpPr>
+        <p:spPr>
+          <a:xfrm>
+            <a:off x="841248" y="1380363"/>
+            <a:ext cx="10509199" cy="19050"/>
+          </a:xfrm>
+          <a:prstGeom prst="rect">
+            <a:avLst/>
+          </a:prstGeom>
+          <a:solidFill>
+            <a:srgbClr val="1F4E5F"/>
+          </a:solidFill>
+          <a:ln>
+            <a:noFill/>
           </a:ln>
           <a:effectLst/>
         </p:spPr>
         <p:style>
-          <a:lnRef idx="2">
+          <a:lnRef idx="1">
             <a:schemeClr val="accent1"/>
           </a:lnRef>
-          <a:fillRef idx="0">
+          <a:fillRef idx="3">
             <a:schemeClr val="accent1"/>
           </a:fillRef>
-          <a:effectRef idx="1">
+          <a:effectRef idx="2">
             <a:schemeClr val="accent1"/>
           </a:effectRef>
           <a:fontRef idx="minor">
-            <a:schemeClr val="tx1"/>
+            <a:schemeClr val="lt1"/>
           </a:fontRef>
         </p:style>
-      </p:cxnSp>
+        <p:txBody>
+          <a:bodyPr rtlCol="0" anchor="ctr"/>
+          <a:lstStyle/>
+          <a:p>
+            <a:pPr algn="ctr"/>
+          </a:p>
+        </p:txBody>
+      </p:sp>
       <p:sp>
         <p:nvSpPr>
           <p:cNvPr id="6" name="TextBox 5"/>
@@ -13548,42 +13644,50 @@
           </a:p>
         </p:txBody>
       </p:sp>
-      <p:cxnSp>
-        <p:nvCxnSpPr>
-          <p:cNvPr id="5" name="Connector 4"/>
-          <p:cNvCxnSpPr/>
-          <p:nvPr/>
-        </p:nvCxnSpPr>
-        <p:spPr>
-          <a:xfrm>
-            <a:off x="841248" y="1389888"/>
-            <a:ext cx="10509199" cy="0"/>
-          </a:xfrm>
-          <a:prstGeom prst="bentConnector3">
-            <a:avLst/>
-          </a:prstGeom>
-          <a:ln w="19050">
-            <a:solidFill>
-              <a:srgbClr val="1F4E5F"/>
-            </a:solidFill>
+      <p:sp>
+        <p:nvSpPr>
+          <p:cNvPr id="5" name="Rectangle 4"/>
+          <p:cNvSpPr/>
+          <p:nvPr/>
+        </p:nvSpPr>
+        <p:spPr>
+          <a:xfrm>
+            <a:off x="841248" y="1380363"/>
+            <a:ext cx="10509199" cy="19050"/>
+          </a:xfrm>
+          <a:prstGeom prst="rect">
+            <a:avLst/>
+          </a:prstGeom>
+          <a:solidFill>
+            <a:srgbClr val="1F4E5F"/>
+          </a:solidFill>
+          <a:ln>
+            <a:noFill/>
           </a:ln>
           <a:effectLst/>
         </p:spPr>
         <p:style>
-          <a:lnRef idx="2">
+          <a:lnRef idx="1">
             <a:schemeClr val="accent1"/>
           </a:lnRef>
-          <a:fillRef idx="0">
+          <a:fillRef idx="3">
             <a:schemeClr val="accent1"/>
           </a:fillRef>
-          <a:effectRef idx="1">
+          <a:effectRef idx="2">
             <a:schemeClr val="accent1"/>
           </a:effectRef>
           <a:fontRef idx="minor">
-            <a:schemeClr val="tx1"/>
+            <a:schemeClr val="lt1"/>
           </a:fontRef>
         </p:style>
-      </p:cxnSp>
+        <p:txBody>
+          <a:bodyPr rtlCol="0" anchor="ctr"/>
+          <a:lstStyle/>
+          <a:p>
+            <a:pPr algn="ctr"/>
+          </a:p>
+        </p:txBody>
+      </p:sp>
       <p:sp>
         <p:nvSpPr>
           <p:cNvPr id="6" name="TextBox 5"/>
@@ -14248,42 +14352,50 @@
           </a:p>
         </p:txBody>
       </p:sp>
-      <p:cxnSp>
-        <p:nvCxnSpPr>
-          <p:cNvPr id="18" name="Connector 17"/>
-          <p:cNvCxnSpPr/>
-          <p:nvPr/>
-        </p:nvCxnSpPr>
-        <p:spPr>
-          <a:xfrm>
-            <a:off x="7366479.44" y="3758184"/>
-            <a:ext cx="3801087.5599999996" cy="0"/>
-          </a:xfrm>
-          <a:prstGeom prst="bentConnector3">
-            <a:avLst/>
-          </a:prstGeom>
-          <a:ln w="12700">
-            <a:solidFill>
-              <a:srgbClr val="D9DEE0"/>
-            </a:solidFill>
+      <p:sp>
+        <p:nvSpPr>
+          <p:cNvPr id="18" name="Rectangle 17"/>
+          <p:cNvSpPr/>
+          <p:nvPr/>
+        </p:nvSpPr>
+        <p:spPr>
+          <a:xfrm>
+            <a:off x="7366479" y="3751834"/>
+            <a:ext cx="3801087" cy="12700"/>
+          </a:xfrm>
+          <a:prstGeom prst="rect">
+            <a:avLst/>
+          </a:prstGeom>
+          <a:solidFill>
+            <a:srgbClr val="D9DEE0"/>
+          </a:solidFill>
+          <a:ln>
+            <a:noFill/>
           </a:ln>
           <a:effectLst/>
         </p:spPr>
         <p:style>
-          <a:lnRef idx="2">
+          <a:lnRef idx="1">
             <a:schemeClr val="accent1"/>
           </a:lnRef>
-          <a:fillRef idx="0">
+          <a:fillRef idx="3">
             <a:schemeClr val="accent1"/>
           </a:fillRef>
-          <a:effectRef idx="1">
+          <a:effectRef idx="2">
             <a:schemeClr val="accent1"/>
           </a:effectRef>
           <a:fontRef idx="minor">
-            <a:schemeClr val="tx1"/>
+            <a:schemeClr val="lt1"/>
           </a:fontRef>
         </p:style>
-      </p:cxnSp>
+        <p:txBody>
+          <a:bodyPr rtlCol="0" anchor="ctr"/>
+          <a:lstStyle/>
+          <a:p>
+            <a:pPr algn="ctr"/>
+          </a:p>
+        </p:txBody>
+      </p:sp>
       <p:sp>
         <p:nvSpPr>
           <p:cNvPr id="19" name="TextBox 18"/>
@@ -14514,42 +14626,50 @@
           </a:p>
         </p:txBody>
       </p:sp>
-      <p:cxnSp>
-        <p:nvCxnSpPr>
-          <p:cNvPr id="5" name="Connector 4"/>
-          <p:cNvCxnSpPr/>
-          <p:nvPr/>
-        </p:nvCxnSpPr>
-        <p:spPr>
-          <a:xfrm>
-            <a:off x="841248" y="1389888"/>
-            <a:ext cx="10509199" cy="0"/>
-          </a:xfrm>
-          <a:prstGeom prst="bentConnector3">
-            <a:avLst/>
-          </a:prstGeom>
-          <a:ln w="19050">
-            <a:solidFill>
-              <a:srgbClr val="1F4E5F"/>
-            </a:solidFill>
+      <p:sp>
+        <p:nvSpPr>
+          <p:cNvPr id="5" name="Rectangle 4"/>
+          <p:cNvSpPr/>
+          <p:nvPr/>
+        </p:nvSpPr>
+        <p:spPr>
+          <a:xfrm>
+            <a:off x="841248" y="1380363"/>
+            <a:ext cx="10509199" cy="19050"/>
+          </a:xfrm>
+          <a:prstGeom prst="rect">
+            <a:avLst/>
+          </a:prstGeom>
+          <a:solidFill>
+            <a:srgbClr val="1F4E5F"/>
+          </a:solidFill>
+          <a:ln>
+            <a:noFill/>
           </a:ln>
           <a:effectLst/>
         </p:spPr>
         <p:style>
-          <a:lnRef idx="2">
+          <a:lnRef idx="1">
             <a:schemeClr val="accent1"/>
           </a:lnRef>
-          <a:fillRef idx="0">
+          <a:fillRef idx="3">
             <a:schemeClr val="accent1"/>
           </a:fillRef>
-          <a:effectRef idx="1">
+          <a:effectRef idx="2">
             <a:schemeClr val="accent1"/>
           </a:effectRef>
           <a:fontRef idx="minor">
-            <a:schemeClr val="tx1"/>
+            <a:schemeClr val="lt1"/>
           </a:fontRef>
         </p:style>
-      </p:cxnSp>
+        <p:txBody>
+          <a:bodyPr rtlCol="0" anchor="ctr"/>
+          <a:lstStyle/>
+          <a:p>
+            <a:pPr algn="ctr"/>
+          </a:p>
+        </p:txBody>
+      </p:sp>
       <p:sp>
         <p:nvSpPr>
           <p:cNvPr id="6" name="TextBox 5"/>
@@ -17081,42 +17201,50 @@
           </a:p>
         </p:txBody>
       </p:sp>
-      <p:cxnSp>
-        <p:nvCxnSpPr>
-          <p:cNvPr id="5" name="Connector 4"/>
-          <p:cNvCxnSpPr/>
-          <p:nvPr/>
-        </p:nvCxnSpPr>
-        <p:spPr>
-          <a:xfrm>
-            <a:off x="841248" y="1389888"/>
-            <a:ext cx="10509199" cy="0"/>
-          </a:xfrm>
-          <a:prstGeom prst="bentConnector3">
-            <a:avLst/>
-          </a:prstGeom>
-          <a:ln w="19050">
-            <a:solidFill>
-              <a:srgbClr val="1F4E5F"/>
-            </a:solidFill>
+      <p:sp>
+        <p:nvSpPr>
+          <p:cNvPr id="5" name="Rectangle 4"/>
+          <p:cNvSpPr/>
+          <p:nvPr/>
+        </p:nvSpPr>
+        <p:spPr>
+          <a:xfrm>
+            <a:off x="841248" y="1380363"/>
+            <a:ext cx="10509199" cy="19050"/>
+          </a:xfrm>
+          <a:prstGeom prst="rect">
+            <a:avLst/>
+          </a:prstGeom>
+          <a:solidFill>
+            <a:srgbClr val="1F4E5F"/>
+          </a:solidFill>
+          <a:ln>
+            <a:noFill/>
           </a:ln>
           <a:effectLst/>
         </p:spPr>
         <p:style>
-          <a:lnRef idx="2">
+          <a:lnRef idx="1">
             <a:schemeClr val="accent1"/>
           </a:lnRef>
-          <a:fillRef idx="0">
+          <a:fillRef idx="3">
             <a:schemeClr val="accent1"/>
           </a:fillRef>
-          <a:effectRef idx="1">
+          <a:effectRef idx="2">
             <a:schemeClr val="accent1"/>
           </a:effectRef>
           <a:fontRef idx="minor">
-            <a:schemeClr val="tx1"/>
+            <a:schemeClr val="lt1"/>
           </a:fontRef>
         </p:style>
-      </p:cxnSp>
+        <p:txBody>
+          <a:bodyPr rtlCol="0" anchor="ctr"/>
+          <a:lstStyle/>
+          <a:p>
+            <a:pPr algn="ctr"/>
+          </a:p>
+        </p:txBody>
+      </p:sp>
       <p:sp>
         <p:nvSpPr>
           <p:cNvPr id="6" name="TextBox 5"/>

</xml_diff>

<commit_message>
feat(plano-b): adiciona slide Meta-FSS (FSS otimiza hiperparametros do PSO)
</commit_message>
<xml_diff>
--- a/plano_b_pso_diabetes/Apresentacao_Equipe4_PlanoB.pptx
+++ b/plano_b_pso_diabetes/Apresentacao_Equipe4_PlanoB.pptx
@@ -19,6 +19,7 @@
     <p:sldId id="267" r:id="rId18"/>
     <p:sldId id="268" r:id="rId19"/>
     <p:sldId id="269" r:id="rId20"/>
+    <p:sldId id="270" r:id="rId21"/>
   </p:sldIdLst>
   <p:sldSz cx="12191695" cy="6858000" type="screen4x3"/>
   <p:notesSz cx="6858000" cy="9144000"/>
@@ -3708,7 +3709,7 @@
                 </a:solidFill>
                 <a:latin typeface="Calibri"/>
               </a:rPr>
-              <a:t>09 / 13</a:t>
+              <a:t>09 / 14</a:t>
             </a:r>
           </a:p>
         </p:txBody>
@@ -4589,7 +4590,7 @@
                 </a:solidFill>
                 <a:latin typeface="Calibri"/>
               </a:rPr>
-              <a:t>10 / 13</a:t>
+              <a:t>10 / 14</a:t>
             </a:r>
           </a:p>
         </p:txBody>
@@ -5047,7 +5048,7 @@
                 </a:solidFill>
                 <a:latin typeface="Calibri"/>
               </a:rPr>
-              <a:t>FECHAMENTO</a:t>
+              <a:t>VALIDAÇÃO E GANHO</a:t>
             </a:r>
           </a:p>
         </p:txBody>
@@ -5089,7 +5090,7 @@
                 </a:solidFill>
                 <a:latin typeface="Cambria"/>
               </a:rPr>
-              <a:t>BFSS, de relance — o plano principal segue vivo</a:t>
+              <a:t>Meta-FSS — o enxame que ajusta o enxame</a:t>
             </a:r>
           </a:p>
         </p:txBody>
@@ -5217,7 +5218,7 @@
                 </a:solidFill>
                 <a:latin typeface="Calibri"/>
               </a:rPr>
-              <a:t>11 / 13</a:t>
+              <a:t>11 / 14</a:t>
             </a:r>
           </a:p>
         </p:txBody>
@@ -5230,8 +5231,8 @@
         </p:nvSpPr>
         <p:spPr>
           <a:xfrm>
-            <a:off x="841248" y="1828800"/>
-            <a:ext cx="6095335" cy="3657600"/>
+            <a:off x="841248" y="1481328"/>
+            <a:ext cx="10509199" cy="320040"/>
           </a:xfrm>
           <a:prstGeom prst="rect">
             <a:avLst/>
@@ -5249,130 +5250,690 @@
                 <a:spcPts val="0"/>
               </a:spcBef>
               <a:spcAft>
-                <a:spcPts val="1000"/>
-              </a:spcAft>
-            </a:pPr>
-            <a:r>
-              <a:rPr sz="1700" b="1" i="0">
-                <a:solidFill>
-                  <a:srgbClr val="2B2B2B"/>
-                </a:solidFill>
-                <a:latin typeface="Cambria"/>
-              </a:rPr>
-              <a:t>Validação por marcadores plantados</a:t>
-            </a:r>
-            <a:r>
-              <a:rPr sz="1450" b="1" i="0">
-                <a:solidFill>
-                  <a:srgbClr val="1F4E5F"/>
-                </a:solidFill>
-                <a:latin typeface="Calibri"/>
-              </a:rPr>
-              <a:t>—  </a:t>
-            </a:r>
-            <a:r>
-              <a:rPr sz="1450" b="0" i="0">
-                <a:solidFill>
-                  <a:srgbClr val="2B2B2B"/>
-                </a:solidFill>
-                <a:latin typeface="Calibri"/>
-              </a:rPr>
-              <a:t>Base sintética com gabarito (verdade-base plantada).</a:t>
-            </a:r>
-          </a:p>
-          <a:p>
-            <a:pPr>
-              <a:spcBef>
-                <a:spcPts val="0"/>
-              </a:spcBef>
-              <a:spcAft>
-                <a:spcPts val="1000"/>
-              </a:spcAft>
-            </a:pPr>
-            <a:r>
-              <a:rPr sz="1450" b="1" i="0">
-                <a:solidFill>
-                  <a:srgbClr val="1F4E5F"/>
-                </a:solidFill>
-                <a:latin typeface="Calibri"/>
-              </a:rPr>
-              <a:t>—  </a:t>
-            </a:r>
-            <a:r>
-              <a:rPr sz="1450" b="0" i="0">
-                <a:solidFill>
-                  <a:srgbClr val="2B2B2B"/>
-                </a:solidFill>
-                <a:latin typeface="Calibri"/>
-              </a:rPr>
-              <a:t>Prova ALGORÍTMICA de que o otimizador recupera o sinal — não é alegação clínica.</a:t>
-            </a:r>
-          </a:p>
-          <a:p>
-            <a:pPr>
-              <a:spcBef>
-                <a:spcPts val="0"/>
-              </a:spcBef>
-              <a:spcAft>
-                <a:spcPts val="1000"/>
-              </a:spcAft>
-            </a:pPr>
-            <a:r>
-              <a:rPr sz="1450" b="1" i="0">
-                <a:solidFill>
-                  <a:srgbClr val="1F4E5F"/>
-                </a:solidFill>
-                <a:latin typeface="Calibri"/>
-              </a:rPr>
-              <a:t>—  </a:t>
-            </a:r>
-            <a:r>
-              <a:rPr sz="1450" b="0" i="0">
-                <a:solidFill>
-                  <a:srgbClr val="2B2B2B"/>
-                </a:solidFill>
-                <a:latin typeface="Calibri"/>
-              </a:rPr>
-              <a:t>Mantém a família de enxame (FSS) como fio condutor do projeto.</a:t>
-            </a:r>
-          </a:p>
-          <a:p>
-            <a:pPr algn="l">
-              <a:spcBef>
                 <a:spcPts val="600"/>
-              </a:spcBef>
-              <a:spcAft>
-                <a:spcPts val="0"/>
-              </a:spcAft>
-            </a:pPr>
-            <a:r>
-              <a:rPr sz="1400" b="0" i="1">
+              </a:spcAft>
+            </a:pPr>
+            <a:r>
+              <a:rPr sz="1350" b="0" i="1">
                 <a:solidFill>
                   <a:srgbClr val="6B7276"/>
                 </a:solidFill>
                 <a:latin typeface="Calibri"/>
               </a:rPr>
-              <a:t>Próximo: MOPSO discreto + NSGA-II para a frente de Pareto.</a:t>
-            </a:r>
-          </a:p>
-        </p:txBody>
-      </p:sp>
-      <p:sp>
-        <p:nvSpPr>
-          <p:cNvPr id="9" name="Rectangle 8"/>
+              <a:t>FSS (Fish School Search) otimiza os hiperparâmetros do PSO — meta-otimização em dois níveis.</a:t>
+            </a:r>
+          </a:p>
+        </p:txBody>
+      </p:sp>
+      <p:sp>
+        <p:nvSpPr>
+          <p:cNvPr id="9" name="Rounded Rectangle 8"/>
           <p:cNvSpPr/>
           <p:nvPr/>
         </p:nvSpPr>
         <p:spPr>
           <a:xfrm>
-            <a:off x="7356951" y="1828800"/>
-            <a:ext cx="3993495" cy="1737360"/>
-          </a:xfrm>
-          <a:prstGeom prst="rect">
+            <a:off x="841248" y="1965960"/>
+            <a:ext cx="3198266" cy="914400"/>
+          </a:xfrm>
+          <a:prstGeom prst="roundRect">
             <a:avLst/>
           </a:prstGeom>
           <a:solidFill>
             <a:srgbClr val="F4F6F7"/>
+          </a:solidFill>
+          <a:ln w="12700">
+            <a:solidFill>
+              <a:srgbClr val="1F4E5F"/>
+            </a:solidFill>
+          </a:ln>
+          <a:effectLst/>
+        </p:spPr>
+        <p:style>
+          <a:lnRef idx="1">
+            <a:schemeClr val="accent1"/>
+          </a:lnRef>
+          <a:fillRef idx="3">
+            <a:schemeClr val="accent1"/>
+          </a:fillRef>
+          <a:effectRef idx="2">
+            <a:schemeClr val="accent1"/>
+          </a:effectRef>
+          <a:fontRef idx="minor">
+            <a:schemeClr val="lt1"/>
+          </a:fontRef>
+        </p:style>
+        <p:txBody>
+          <a:bodyPr rtlCol="0" anchor="ctr"/>
+          <a:lstStyle/>
+          <a:p>
+            <a:pPr algn="ctr"/>
+          </a:p>
+        </p:txBody>
+      </p:sp>
+      <p:sp>
+        <p:nvSpPr>
+          <p:cNvPr id="10" name="Rectangle 9"/>
+          <p:cNvSpPr/>
+          <p:nvPr/>
+        </p:nvSpPr>
+        <p:spPr>
+          <a:xfrm>
+            <a:off x="841248" y="1965960"/>
+            <a:ext cx="91440" cy="914400"/>
+          </a:xfrm>
+          <a:prstGeom prst="rect">
+            <a:avLst/>
+          </a:prstGeom>
+          <a:solidFill>
+            <a:srgbClr val="1F4E5F"/>
+          </a:solidFill>
+          <a:ln>
+            <a:noFill/>
+          </a:ln>
+          <a:effectLst/>
+        </p:spPr>
+        <p:style>
+          <a:lnRef idx="1">
+            <a:schemeClr val="accent1"/>
+          </a:lnRef>
+          <a:fillRef idx="3">
+            <a:schemeClr val="accent1"/>
+          </a:fillRef>
+          <a:effectRef idx="2">
+            <a:schemeClr val="accent1"/>
+          </a:effectRef>
+          <a:fontRef idx="minor">
+            <a:schemeClr val="lt1"/>
+          </a:fontRef>
+        </p:style>
+        <p:txBody>
+          <a:bodyPr rtlCol="0" anchor="ctr"/>
+          <a:lstStyle/>
+          <a:p>
+            <a:pPr algn="ctr"/>
+          </a:p>
+        </p:txBody>
+      </p:sp>
+      <p:sp>
+        <p:nvSpPr>
+          <p:cNvPr id="11" name="TextBox 10"/>
+          <p:cNvSpPr txBox="1"/>
+          <p:nvPr/>
+        </p:nvSpPr>
+        <p:spPr>
+          <a:xfrm>
+            <a:off x="1133856" y="2148840"/>
+            <a:ext cx="2741066" cy="640080"/>
+          </a:xfrm>
+          <a:prstGeom prst="rect">
+            <a:avLst/>
+          </a:prstGeom>
+          <a:noFill/>
+        </p:spPr>
+        <p:txBody>
+          <a:bodyPr wrap="square" lIns="0" rIns="0" tIns="0" bIns="0">
+            <a:spAutoFit/>
+          </a:bodyPr>
+          <a:lstStyle/>
+          <a:p>
+            <a:pPr algn="l">
+              <a:spcBef>
+                <a:spcPts val="0"/>
+              </a:spcBef>
+              <a:spcAft>
+                <a:spcPts val="200"/>
+              </a:spcAft>
+            </a:pPr>
+            <a:r>
+              <a:rPr sz="1450" b="1" i="0">
+                <a:solidFill>
+                  <a:srgbClr val="2B2B2B"/>
+                </a:solidFill>
+                <a:latin typeface="Calibri"/>
+              </a:rPr>
+              <a:t>FSS — meta-nível</a:t>
+            </a:r>
+          </a:p>
+          <a:p>
+            <a:pPr algn="l">
+              <a:spcBef>
+                <a:spcPts val="0"/>
+              </a:spcBef>
+              <a:spcAft>
+                <a:spcPts val="0"/>
+              </a:spcAft>
+            </a:pPr>
+            <a:r>
+              <a:rPr sz="1200" b="0" i="0">
+                <a:solidFill>
+                  <a:srgbClr val="6B7276"/>
+                </a:solidFill>
+                <a:latin typeface="Calibri"/>
+              </a:rPr>
+              <a:t>ajusta w, c1, c2, λ</a:t>
+            </a:r>
+          </a:p>
+        </p:txBody>
+      </p:sp>
+      <p:sp>
+        <p:nvSpPr>
+          <p:cNvPr id="12" name="TextBox 11"/>
+          <p:cNvSpPr txBox="1"/>
+          <p:nvPr/>
+        </p:nvSpPr>
+        <p:spPr>
+          <a:xfrm>
+            <a:off x="4076090" y="2185416"/>
+            <a:ext cx="384048" cy="457200"/>
+          </a:xfrm>
+          <a:prstGeom prst="rect">
+            <a:avLst/>
+          </a:prstGeom>
+          <a:noFill/>
+        </p:spPr>
+        <p:txBody>
+          <a:bodyPr wrap="square" lIns="0" rIns="0" tIns="0" bIns="0">
+            <a:spAutoFit/>
+          </a:bodyPr>
+          <a:lstStyle/>
+          <a:p>
+            <a:pPr algn="ctr">
+              <a:spcBef>
+                <a:spcPts val="0"/>
+              </a:spcBef>
+              <a:spcAft>
+                <a:spcPts val="600"/>
+              </a:spcAft>
+            </a:pPr>
+            <a:r>
+              <a:rPr sz="2200" b="1" i="0">
+                <a:solidFill>
+                  <a:srgbClr val="6B7276"/>
+                </a:solidFill>
+                <a:latin typeface="Calibri"/>
+              </a:rPr>
+              <a:t>→</a:t>
+            </a:r>
+          </a:p>
+        </p:txBody>
+      </p:sp>
+      <p:sp>
+        <p:nvSpPr>
+          <p:cNvPr id="13" name="Rounded Rectangle 12"/>
+          <p:cNvSpPr/>
+          <p:nvPr/>
+        </p:nvSpPr>
+        <p:spPr>
+          <a:xfrm>
+            <a:off x="4496714" y="1965960"/>
+            <a:ext cx="3198266" cy="914400"/>
+          </a:xfrm>
+          <a:prstGeom prst="roundRect">
+            <a:avLst/>
+          </a:prstGeom>
+          <a:solidFill>
+            <a:srgbClr val="F4F6F7"/>
+          </a:solidFill>
+          <a:ln w="12700">
+            <a:solidFill>
+              <a:srgbClr val="3C7A8C"/>
+            </a:solidFill>
+          </a:ln>
+          <a:effectLst/>
+        </p:spPr>
+        <p:style>
+          <a:lnRef idx="1">
+            <a:schemeClr val="accent1"/>
+          </a:lnRef>
+          <a:fillRef idx="3">
+            <a:schemeClr val="accent1"/>
+          </a:fillRef>
+          <a:effectRef idx="2">
+            <a:schemeClr val="accent1"/>
+          </a:effectRef>
+          <a:fontRef idx="minor">
+            <a:schemeClr val="lt1"/>
+          </a:fontRef>
+        </p:style>
+        <p:txBody>
+          <a:bodyPr rtlCol="0" anchor="ctr"/>
+          <a:lstStyle/>
+          <a:p>
+            <a:pPr algn="ctr"/>
+          </a:p>
+        </p:txBody>
+      </p:sp>
+      <p:sp>
+        <p:nvSpPr>
+          <p:cNvPr id="14" name="Rectangle 13"/>
+          <p:cNvSpPr/>
+          <p:nvPr/>
+        </p:nvSpPr>
+        <p:spPr>
+          <a:xfrm>
+            <a:off x="4496714" y="1965960"/>
+            <a:ext cx="91440" cy="914400"/>
+          </a:xfrm>
+          <a:prstGeom prst="rect">
+            <a:avLst/>
+          </a:prstGeom>
+          <a:solidFill>
+            <a:srgbClr val="3C7A8C"/>
+          </a:solidFill>
+          <a:ln>
+            <a:noFill/>
+          </a:ln>
+          <a:effectLst/>
+        </p:spPr>
+        <p:style>
+          <a:lnRef idx="1">
+            <a:schemeClr val="accent1"/>
+          </a:lnRef>
+          <a:fillRef idx="3">
+            <a:schemeClr val="accent1"/>
+          </a:fillRef>
+          <a:effectRef idx="2">
+            <a:schemeClr val="accent1"/>
+          </a:effectRef>
+          <a:fontRef idx="minor">
+            <a:schemeClr val="lt1"/>
+          </a:fontRef>
+        </p:style>
+        <p:txBody>
+          <a:bodyPr rtlCol="0" anchor="ctr"/>
+          <a:lstStyle/>
+          <a:p>
+            <a:pPr algn="ctr"/>
+          </a:p>
+        </p:txBody>
+      </p:sp>
+      <p:sp>
+        <p:nvSpPr>
+          <p:cNvPr id="15" name="TextBox 14"/>
+          <p:cNvSpPr txBox="1"/>
+          <p:nvPr/>
+        </p:nvSpPr>
+        <p:spPr>
+          <a:xfrm>
+            <a:off x="4789322" y="2148840"/>
+            <a:ext cx="2741066" cy="640080"/>
+          </a:xfrm>
+          <a:prstGeom prst="rect">
+            <a:avLst/>
+          </a:prstGeom>
+          <a:noFill/>
+        </p:spPr>
+        <p:txBody>
+          <a:bodyPr wrap="square" lIns="0" rIns="0" tIns="0" bIns="0">
+            <a:spAutoFit/>
+          </a:bodyPr>
+          <a:lstStyle/>
+          <a:p>
+            <a:pPr algn="l">
+              <a:spcBef>
+                <a:spcPts val="0"/>
+              </a:spcBef>
+              <a:spcAft>
+                <a:spcPts val="200"/>
+              </a:spcAft>
+            </a:pPr>
+            <a:r>
+              <a:rPr sz="1450" b="1" i="0">
+                <a:solidFill>
+                  <a:srgbClr val="2B2B2B"/>
+                </a:solidFill>
+                <a:latin typeface="Calibri"/>
+              </a:rPr>
+              <a:t>PSO — nível 1</a:t>
+            </a:r>
+          </a:p>
+          <a:p>
+            <a:pPr algn="l">
+              <a:spcBef>
+                <a:spcPts val="0"/>
+              </a:spcBef>
+              <a:spcAft>
+                <a:spcPts val="0"/>
+              </a:spcAft>
+            </a:pPr>
+            <a:r>
+              <a:rPr sz="1200" b="0" i="0">
+                <a:solidFill>
+                  <a:srgbClr val="6B7276"/>
+                </a:solidFill>
+                <a:latin typeface="Calibri"/>
+              </a:rPr>
+              <a:t>otimiza os pesos do modelo</a:t>
+            </a:r>
+          </a:p>
+        </p:txBody>
+      </p:sp>
+      <p:sp>
+        <p:nvSpPr>
+          <p:cNvPr id="16" name="TextBox 15"/>
+          <p:cNvSpPr txBox="1"/>
+          <p:nvPr/>
+        </p:nvSpPr>
+        <p:spPr>
+          <a:xfrm>
+            <a:off x="7731556" y="2185416"/>
+            <a:ext cx="384048" cy="457200"/>
+          </a:xfrm>
+          <a:prstGeom prst="rect">
+            <a:avLst/>
+          </a:prstGeom>
+          <a:noFill/>
+        </p:spPr>
+        <p:txBody>
+          <a:bodyPr wrap="square" lIns="0" rIns="0" tIns="0" bIns="0">
+            <a:spAutoFit/>
+          </a:bodyPr>
+          <a:lstStyle/>
+          <a:p>
+            <a:pPr algn="ctr">
+              <a:spcBef>
+                <a:spcPts val="0"/>
+              </a:spcBef>
+              <a:spcAft>
+                <a:spcPts val="600"/>
+              </a:spcAft>
+            </a:pPr>
+            <a:r>
+              <a:rPr sz="2200" b="1" i="0">
+                <a:solidFill>
+                  <a:srgbClr val="6B7276"/>
+                </a:solidFill>
+                <a:latin typeface="Calibri"/>
+              </a:rPr>
+              <a:t>→</a:t>
+            </a:r>
+          </a:p>
+        </p:txBody>
+      </p:sp>
+      <p:sp>
+        <p:nvSpPr>
+          <p:cNvPr id="17" name="Rounded Rectangle 16"/>
+          <p:cNvSpPr/>
+          <p:nvPr/>
+        </p:nvSpPr>
+        <p:spPr>
+          <a:xfrm>
+            <a:off x="8152180" y="1965960"/>
+            <a:ext cx="3198266" cy="914400"/>
+          </a:xfrm>
+          <a:prstGeom prst="roundRect">
+            <a:avLst/>
+          </a:prstGeom>
+          <a:solidFill>
+            <a:srgbClr val="F4F6F7"/>
+          </a:solidFill>
+          <a:ln w="12700">
+            <a:solidFill>
+              <a:srgbClr val="2E6B4F"/>
+            </a:solidFill>
+          </a:ln>
+          <a:effectLst/>
+        </p:spPr>
+        <p:style>
+          <a:lnRef idx="1">
+            <a:schemeClr val="accent1"/>
+          </a:lnRef>
+          <a:fillRef idx="3">
+            <a:schemeClr val="accent1"/>
+          </a:fillRef>
+          <a:effectRef idx="2">
+            <a:schemeClr val="accent1"/>
+          </a:effectRef>
+          <a:fontRef idx="minor">
+            <a:schemeClr val="lt1"/>
+          </a:fontRef>
+        </p:style>
+        <p:txBody>
+          <a:bodyPr rtlCol="0" anchor="ctr"/>
+          <a:lstStyle/>
+          <a:p>
+            <a:pPr algn="ctr"/>
+          </a:p>
+        </p:txBody>
+      </p:sp>
+      <p:sp>
+        <p:nvSpPr>
+          <p:cNvPr id="18" name="Rectangle 17"/>
+          <p:cNvSpPr/>
+          <p:nvPr/>
+        </p:nvSpPr>
+        <p:spPr>
+          <a:xfrm>
+            <a:off x="8152180" y="1965960"/>
+            <a:ext cx="91440" cy="914400"/>
+          </a:xfrm>
+          <a:prstGeom prst="rect">
+            <a:avLst/>
+          </a:prstGeom>
+          <a:solidFill>
+            <a:srgbClr val="2E6B4F"/>
+          </a:solidFill>
+          <a:ln>
+            <a:noFill/>
+          </a:ln>
+          <a:effectLst/>
+        </p:spPr>
+        <p:style>
+          <a:lnRef idx="1">
+            <a:schemeClr val="accent1"/>
+          </a:lnRef>
+          <a:fillRef idx="3">
+            <a:schemeClr val="accent1"/>
+          </a:fillRef>
+          <a:effectRef idx="2">
+            <a:schemeClr val="accent1"/>
+          </a:effectRef>
+          <a:fontRef idx="minor">
+            <a:schemeClr val="lt1"/>
+          </a:fontRef>
+        </p:style>
+        <p:txBody>
+          <a:bodyPr rtlCol="0" anchor="ctr"/>
+          <a:lstStyle/>
+          <a:p>
+            <a:pPr algn="ctr"/>
+          </a:p>
+        </p:txBody>
+      </p:sp>
+      <p:sp>
+        <p:nvSpPr>
+          <p:cNvPr id="19" name="TextBox 18"/>
+          <p:cNvSpPr txBox="1"/>
+          <p:nvPr/>
+        </p:nvSpPr>
+        <p:spPr>
+          <a:xfrm>
+            <a:off x="8444788" y="2148840"/>
+            <a:ext cx="2741066" cy="640080"/>
+          </a:xfrm>
+          <a:prstGeom prst="rect">
+            <a:avLst/>
+          </a:prstGeom>
+          <a:noFill/>
+        </p:spPr>
+        <p:txBody>
+          <a:bodyPr wrap="square" lIns="0" rIns="0" tIns="0" bIns="0">
+            <a:spAutoFit/>
+          </a:bodyPr>
+          <a:lstStyle/>
+          <a:p>
+            <a:pPr algn="l">
+              <a:spcBef>
+                <a:spcPts val="0"/>
+              </a:spcBef>
+              <a:spcAft>
+                <a:spcPts val="200"/>
+              </a:spcAft>
+            </a:pPr>
+            <a:r>
+              <a:rPr sz="1450" b="1" i="0">
+                <a:solidFill>
+                  <a:srgbClr val="2B2B2B"/>
+                </a:solidFill>
+                <a:latin typeface="Calibri"/>
+              </a:rPr>
+              <a:t>Regressão logística</a:t>
+            </a:r>
+          </a:p>
+          <a:p>
+            <a:pPr algn="l">
+              <a:spcBef>
+                <a:spcPts val="0"/>
+              </a:spcBef>
+              <a:spcAft>
+                <a:spcPts val="0"/>
+              </a:spcAft>
+            </a:pPr>
+            <a:r>
+              <a:rPr sz="1200" b="0" i="0">
+                <a:solidFill>
+                  <a:srgbClr val="6B7276"/>
+                </a:solidFill>
+                <a:latin typeface="Calibri"/>
+              </a:rPr>
+              <a:t>classifica o Wellness</a:t>
+            </a:r>
+          </a:p>
+        </p:txBody>
+      </p:sp>
+      <p:sp>
+        <p:nvSpPr>
+          <p:cNvPr id="20" name="TextBox 19"/>
+          <p:cNvSpPr txBox="1"/>
+          <p:nvPr/>
+        </p:nvSpPr>
+        <p:spPr>
+          <a:xfrm>
+            <a:off x="841248" y="3246120"/>
+            <a:ext cx="4834231" cy="2103120"/>
+          </a:xfrm>
+          <a:prstGeom prst="rect">
+            <a:avLst/>
+          </a:prstGeom>
+          <a:noFill/>
+        </p:spPr>
+        <p:txBody>
+          <a:bodyPr wrap="square" lIns="0" rIns="0" tIns="0" bIns="0">
+            <a:spAutoFit/>
+          </a:bodyPr>
+          <a:lstStyle/>
+          <a:p>
+            <a:pPr algn="l">
+              <a:spcBef>
+                <a:spcPts val="0"/>
+              </a:spcBef>
+              <a:spcAft>
+                <a:spcPts val="1000"/>
+              </a:spcAft>
+            </a:pPr>
+            <a:r>
+              <a:rPr sz="1450" b="1" i="0">
+                <a:solidFill>
+                  <a:srgbClr val="1F4E5F"/>
+                </a:solidFill>
+                <a:latin typeface="Calibri"/>
+              </a:rPr>
+              <a:t>Hiperparâmetros encontrados pelo FSS</a:t>
+            </a:r>
+            <a:r>
+              <a:rPr sz="1350" b="1" i="0">
+                <a:solidFill>
+                  <a:srgbClr val="1F4E5F"/>
+                </a:solidFill>
+                <a:latin typeface="Calibri"/>
+              </a:rPr>
+              <a:t>—  </a:t>
+            </a:r>
+            <a:r>
+              <a:rPr sz="1350" b="0" i="0">
+                <a:solidFill>
+                  <a:srgbClr val="2B2B2B"/>
+                </a:solidFill>
+                <a:latin typeface="Calibri"/>
+              </a:rPr>
+              <a:t>w = 0,67  ·  c1 = 0,74  ·  c2 = 0,59  ·  λ = 0,016</a:t>
+            </a:r>
+          </a:p>
+          <a:p>
+            <a:pPr>
+              <a:spcBef>
+                <a:spcPts val="0"/>
+              </a:spcBef>
+              <a:spcAft>
+                <a:spcPts val="1000"/>
+              </a:spcAft>
+            </a:pPr>
+            <a:r>
+              <a:rPr sz="1350" b="1" i="0">
+                <a:solidFill>
+                  <a:srgbClr val="1F4E5F"/>
+                </a:solidFill>
+                <a:latin typeface="Calibri"/>
+              </a:rPr>
+              <a:t>—  </a:t>
+            </a:r>
+            <a:r>
+              <a:rPr sz="1350" b="0" i="0">
+                <a:solidFill>
+                  <a:srgbClr val="2B2B2B"/>
+                </a:solidFill>
+                <a:latin typeface="Calibri"/>
+              </a:rPr>
+              <a:t>AUC teste: 0,678 (meta)  vs  0,664 (padrão)  →  +0,014</a:t>
+            </a:r>
+          </a:p>
+          <a:p>
+            <a:pPr>
+              <a:spcBef>
+                <a:spcPts val="0"/>
+              </a:spcBef>
+              <a:spcAft>
+                <a:spcPts val="1000"/>
+              </a:spcAft>
+            </a:pPr>
+            <a:r>
+              <a:rPr sz="1350" b="1" i="0">
+                <a:solidFill>
+                  <a:srgbClr val="1F4E5F"/>
+                </a:solidFill>
+                <a:latin typeface="Calibri"/>
+              </a:rPr>
+              <a:t>—  </a:t>
+            </a:r>
+            <a:r>
+              <a:rPr sz="1350" b="0" i="0">
+                <a:solidFill>
+                  <a:srgbClr val="2B2B2B"/>
+                </a:solidFill>
+                <a:latin typeface="Calibri"/>
+              </a:rPr>
+              <a:t>Avaliação por CV-3 no treino (sem tocar no teste).</a:t>
+            </a:r>
+          </a:p>
+        </p:txBody>
+      </p:sp>
+      <p:sp>
+        <p:nvSpPr>
+          <p:cNvPr id="21" name="Rectangle 20"/>
+          <p:cNvSpPr/>
+          <p:nvPr/>
+        </p:nvSpPr>
+        <p:spPr>
+          <a:xfrm>
+            <a:off x="6132679" y="3154680"/>
+            <a:ext cx="5217767" cy="2240280"/>
+          </a:xfrm>
+          <a:prstGeom prst="rect">
+            <a:avLst/>
+          </a:prstGeom>
+          <a:solidFill>
+            <a:srgbClr val="FFFFFF"/>
           </a:solidFill>
           <a:ln w="9525">
             <a:solidFill>
@@ -5403,25 +5964,51 @@
           </a:p>
         </p:txBody>
       </p:sp>
-      <p:sp>
-        <p:nvSpPr>
-          <p:cNvPr id="10" name="Rectangle 9"/>
+      <p:pic>
+        <p:nvPicPr>
+          <p:cNvPr id="22" name="Picture 21" descr="resultados_comparacao_convergencia.png"/>
+          <p:cNvPicPr>
+            <a:picLocks noChangeAspect="1"/>
+          </p:cNvPicPr>
+          <p:nvPr/>
+        </p:nvPicPr>
+        <p:blipFill>
+          <a:blip r:embed="rId2"/>
+          <a:stretch>
+            <a:fillRect/>
+          </a:stretch>
+        </p:blipFill>
+        <p:spPr>
+          <a:xfrm>
+            <a:off x="6997345" y="3291840"/>
+            <a:ext cx="3488436" cy="1993392"/>
+          </a:xfrm>
+          <a:prstGeom prst="rect">
+            <a:avLst/>
+          </a:prstGeom>
+        </p:spPr>
+      </p:pic>
+      <p:sp>
+        <p:nvSpPr>
+          <p:cNvPr id="23" name="Rectangle 22"/>
           <p:cNvSpPr/>
           <p:nvPr/>
         </p:nvSpPr>
         <p:spPr>
           <a:xfrm>
-            <a:off x="7356951" y="1828800"/>
-            <a:ext cx="3993495" cy="91440"/>
+            <a:off x="841248" y="5559552"/>
+            <a:ext cx="10509199" cy="713232"/>
           </a:xfrm>
           <a:prstGeom prst="rect">
             <a:avLst/>
           </a:prstGeom>
           <a:solidFill>
-            <a:srgbClr val="2E6B4F"/>
+            <a:srgbClr val="F4F6F7"/>
           </a:solidFill>
-          <a:ln>
-            <a:noFill/>
+          <a:ln w="12700">
+            <a:solidFill>
+              <a:srgbClr val="3C7A8C"/>
+            </a:solidFill>
           </a:ln>
           <a:effectLst/>
         </p:spPr>
@@ -5449,14 +6036,14 @@
       </p:sp>
       <p:sp>
         <p:nvSpPr>
-          <p:cNvPr id="11" name="TextBox 10"/>
+          <p:cNvPr id="24" name="TextBox 23"/>
           <p:cNvSpPr txBox="1"/>
           <p:nvPr/>
         </p:nvSpPr>
         <p:spPr>
           <a:xfrm>
-            <a:off x="7631271" y="2057400"/>
-            <a:ext cx="3444855" cy="1371600"/>
+            <a:off x="1115568" y="5669280"/>
+            <a:ext cx="9960559" cy="548640"/>
           </a:xfrm>
           <a:prstGeom prst="rect">
             <a:avLst/>
@@ -5474,55 +6061,17 @@
                 <a:spcPts val="0"/>
               </a:spcBef>
               <a:spcAft>
-                <a:spcPts val="400"/>
-              </a:spcAft>
-            </a:pPr>
-            <a:r>
-              <a:rPr sz="1100" b="1" i="0">
-                <a:solidFill>
-                  <a:srgbClr val="6B7276"/>
-                </a:solidFill>
-                <a:latin typeface="Calibri"/>
-              </a:rPr>
-              <a:t>STATUS</a:t>
-            </a:r>
-          </a:p>
-          <a:p>
-            <a:pPr algn="l">
-              <a:spcBef>
-                <a:spcPts val="0"/>
-              </a:spcBef>
-              <a:spcAft>
                 <a:spcPts val="600"/>
               </a:spcAft>
             </a:pPr>
             <a:r>
-              <a:rPr sz="1800" b="1" i="0">
-                <a:solidFill>
-                  <a:srgbClr val="2E6B4F"/>
-                </a:solidFill>
-                <a:latin typeface="Cambria"/>
-              </a:rPr>
-              <a:t>BFSS validado</a:t>
-            </a:r>
-          </a:p>
-          <a:p>
-            <a:pPr algn="l">
-              <a:spcBef>
-                <a:spcPts val="0"/>
-              </a:spcBef>
-              <a:spcAft>
-                <a:spcPts val="0"/>
-              </a:spcAft>
-            </a:pPr>
-            <a:r>
-              <a:rPr sz="1300" b="0" i="0">
+              <a:rPr sz="1200" b="0" i="1">
                 <a:solidFill>
                   <a:srgbClr val="2B2B2B"/>
                 </a:solidFill>
                 <a:latin typeface="Calibri"/>
               </a:rPr>
-              <a:t>Recuperou 8 de 9 marcadores plantados; o subconjunto selecionado eleva o R².</a:t>
+              <a:t>Leitura honesta: o ganho (+0,014) está dentro do ruído da estimativa (IC ≈ 0,68 ± 0,15) e parte vem do afrouxamento do L2. O ponto não é o número — é mostrar a família FSS (Semana #11) governando o PSO.</a:t>
             </a:r>
           </a:p>
         </p:txBody>
@@ -5668,7 +6217,7 @@
                 </a:solidFill>
                 <a:latin typeface="Cambria"/>
               </a:rPr>
-              <a:t>Limitações declaradas</a:t>
+              <a:t>BFSS, de relance — o plano principal segue vivo</a:t>
             </a:r>
           </a:p>
         </p:txBody>
@@ -5796,21 +6345,156 @@
                 </a:solidFill>
                 <a:latin typeface="Calibri"/>
               </a:rPr>
-              <a:t>12 / 13</a:t>
-            </a:r>
-          </a:p>
-        </p:txBody>
-      </p:sp>
-      <p:sp>
-        <p:nvSpPr>
-          <p:cNvPr id="8" name="Rectangle 7"/>
+              <a:t>12 / 14</a:t>
+            </a:r>
+          </a:p>
+        </p:txBody>
+      </p:sp>
+      <p:sp>
+        <p:nvSpPr>
+          <p:cNvPr id="8" name="TextBox 7"/>
+          <p:cNvSpPr txBox="1"/>
+          <p:nvPr/>
+        </p:nvSpPr>
+        <p:spPr>
+          <a:xfrm>
+            <a:off x="841248" y="1828800"/>
+            <a:ext cx="6095335" cy="3657600"/>
+          </a:xfrm>
+          <a:prstGeom prst="rect">
+            <a:avLst/>
+          </a:prstGeom>
+          <a:noFill/>
+        </p:spPr>
+        <p:txBody>
+          <a:bodyPr wrap="square" lIns="0" rIns="0" tIns="0" bIns="0">
+            <a:spAutoFit/>
+          </a:bodyPr>
+          <a:lstStyle/>
+          <a:p>
+            <a:pPr algn="l">
+              <a:spcBef>
+                <a:spcPts val="0"/>
+              </a:spcBef>
+              <a:spcAft>
+                <a:spcPts val="1000"/>
+              </a:spcAft>
+            </a:pPr>
+            <a:r>
+              <a:rPr sz="1700" b="1" i="0">
+                <a:solidFill>
+                  <a:srgbClr val="2B2B2B"/>
+                </a:solidFill>
+                <a:latin typeface="Cambria"/>
+              </a:rPr>
+              <a:t>Validação por marcadores plantados</a:t>
+            </a:r>
+            <a:r>
+              <a:rPr sz="1450" b="1" i="0">
+                <a:solidFill>
+                  <a:srgbClr val="1F4E5F"/>
+                </a:solidFill>
+                <a:latin typeface="Calibri"/>
+              </a:rPr>
+              <a:t>—  </a:t>
+            </a:r>
+            <a:r>
+              <a:rPr sz="1450" b="0" i="0">
+                <a:solidFill>
+                  <a:srgbClr val="2B2B2B"/>
+                </a:solidFill>
+                <a:latin typeface="Calibri"/>
+              </a:rPr>
+              <a:t>Base sintética com gabarito (verdade-base plantada).</a:t>
+            </a:r>
+          </a:p>
+          <a:p>
+            <a:pPr>
+              <a:spcBef>
+                <a:spcPts val="0"/>
+              </a:spcBef>
+              <a:spcAft>
+                <a:spcPts val="1000"/>
+              </a:spcAft>
+            </a:pPr>
+            <a:r>
+              <a:rPr sz="1450" b="1" i="0">
+                <a:solidFill>
+                  <a:srgbClr val="1F4E5F"/>
+                </a:solidFill>
+                <a:latin typeface="Calibri"/>
+              </a:rPr>
+              <a:t>—  </a:t>
+            </a:r>
+            <a:r>
+              <a:rPr sz="1450" b="0" i="0">
+                <a:solidFill>
+                  <a:srgbClr val="2B2B2B"/>
+                </a:solidFill>
+                <a:latin typeface="Calibri"/>
+              </a:rPr>
+              <a:t>Prova ALGORÍTMICA de que o otimizador recupera o sinal — não é alegação clínica.</a:t>
+            </a:r>
+          </a:p>
+          <a:p>
+            <a:pPr>
+              <a:spcBef>
+                <a:spcPts val="0"/>
+              </a:spcBef>
+              <a:spcAft>
+                <a:spcPts val="1000"/>
+              </a:spcAft>
+            </a:pPr>
+            <a:r>
+              <a:rPr sz="1450" b="1" i="0">
+                <a:solidFill>
+                  <a:srgbClr val="1F4E5F"/>
+                </a:solidFill>
+                <a:latin typeface="Calibri"/>
+              </a:rPr>
+              <a:t>—  </a:t>
+            </a:r>
+            <a:r>
+              <a:rPr sz="1450" b="0" i="0">
+                <a:solidFill>
+                  <a:srgbClr val="2B2B2B"/>
+                </a:solidFill>
+                <a:latin typeface="Calibri"/>
+              </a:rPr>
+              <a:t>Mantém a família de enxame (FSS) como fio condutor do projeto.</a:t>
+            </a:r>
+          </a:p>
+          <a:p>
+            <a:pPr algn="l">
+              <a:spcBef>
+                <a:spcPts val="600"/>
+              </a:spcBef>
+              <a:spcAft>
+                <a:spcPts val="0"/>
+              </a:spcAft>
+            </a:pPr>
+            <a:r>
+              <a:rPr sz="1400" b="0" i="1">
+                <a:solidFill>
+                  <a:srgbClr val="6B7276"/>
+                </a:solidFill>
+                <a:latin typeface="Calibri"/>
+              </a:rPr>
+              <a:t>Próximo: MOPSO discreto + NSGA-II para a frente de Pareto.</a:t>
+            </a:r>
+          </a:p>
+        </p:txBody>
+      </p:sp>
+      <p:sp>
+        <p:nvSpPr>
+          <p:cNvPr id="9" name="Rectangle 8"/>
           <p:cNvSpPr/>
           <p:nvPr/>
         </p:nvSpPr>
         <p:spPr>
           <a:xfrm>
-            <a:off x="841248" y="1828800"/>
-            <a:ext cx="5025999" cy="1143000"/>
+            <a:off x="7356951" y="1828800"/>
+            <a:ext cx="3993495" cy="1737360"/>
           </a:xfrm>
           <a:prstGeom prst="rect">
             <a:avLst/>
@@ -5849,20 +6533,20 @@
       </p:sp>
       <p:sp>
         <p:nvSpPr>
-          <p:cNvPr id="9" name="Rectangle 8"/>
+          <p:cNvPr id="10" name="Rectangle 9"/>
           <p:cNvSpPr/>
           <p:nvPr/>
         </p:nvSpPr>
         <p:spPr>
           <a:xfrm>
-            <a:off x="841248" y="1828800"/>
-            <a:ext cx="91440" cy="1143000"/>
+            <a:off x="7356951" y="1828800"/>
+            <a:ext cx="3993495" cy="91440"/>
           </a:xfrm>
           <a:prstGeom prst="rect">
             <a:avLst/>
           </a:prstGeom>
           <a:solidFill>
-            <a:srgbClr val="3C7A8C"/>
+            <a:srgbClr val="2E6B4F"/>
           </a:solidFill>
           <a:ln>
             <a:noFill/>
@@ -5893,14 +6577,14 @@
       </p:sp>
       <p:sp>
         <p:nvSpPr>
-          <p:cNvPr id="10" name="TextBox 9"/>
+          <p:cNvPr id="11" name="TextBox 10"/>
           <p:cNvSpPr txBox="1"/>
           <p:nvPr/>
         </p:nvSpPr>
         <p:spPr>
           <a:xfrm>
-            <a:off x="1115568" y="2029968"/>
-            <a:ext cx="4523079" cy="868680"/>
+            <a:off x="7631271" y="2057400"/>
+            <a:ext cx="3444855" cy="1371600"/>
           </a:xfrm>
           <a:prstGeom prst="rect">
             <a:avLst/>
@@ -5918,677 +6602,55 @@
                 <a:spcPts val="0"/>
               </a:spcBef>
               <a:spcAft>
+                <a:spcPts val="400"/>
+              </a:spcAft>
+            </a:pPr>
+            <a:r>
+              <a:rPr sz="1100" b="1" i="0">
+                <a:solidFill>
+                  <a:srgbClr val="6B7276"/>
+                </a:solidFill>
+                <a:latin typeface="Calibri"/>
+              </a:rPr>
+              <a:t>STATUS</a:t>
+            </a:r>
+          </a:p>
+          <a:p>
+            <a:pPr algn="l">
+              <a:spcBef>
+                <a:spcPts val="0"/>
+              </a:spcBef>
+              <a:spcAft>
                 <a:spcPts val="600"/>
               </a:spcAft>
             </a:pPr>
             <a:r>
-              <a:rPr sz="1350" b="0" i="0">
+              <a:rPr sz="1800" b="1" i="0">
+                <a:solidFill>
+                  <a:srgbClr val="2E6B4F"/>
+                </a:solidFill>
+                <a:latin typeface="Cambria"/>
+              </a:rPr>
+              <a:t>BFSS validado</a:t>
+            </a:r>
+          </a:p>
+          <a:p>
+            <a:pPr algn="l">
+              <a:spcBef>
+                <a:spcPts val="0"/>
+              </a:spcBef>
+              <a:spcAft>
+                <a:spcPts val="0"/>
+              </a:spcAft>
+            </a:pPr>
+            <a:r>
+              <a:rPr sz="1300" b="0" i="0">
                 <a:solidFill>
                   <a:srgbClr val="2B2B2B"/>
                 </a:solidFill>
                 <a:latin typeface="Calibri"/>
               </a:rPr>
-              <a:t>A base não distingue T1D/T2D → 'diabetes tipo não especificado'; é testbed, não evidência clínica.</a:t>
-            </a:r>
-          </a:p>
-        </p:txBody>
-      </p:sp>
-      <p:sp>
-        <p:nvSpPr>
-          <p:cNvPr id="11" name="Rectangle 10"/>
-          <p:cNvSpPr/>
-          <p:nvPr/>
-        </p:nvSpPr>
-        <p:spPr>
-          <a:xfrm>
-            <a:off x="6324447" y="1828800"/>
-            <a:ext cx="5025999" cy="1143000"/>
-          </a:xfrm>
-          <a:prstGeom prst="rect">
-            <a:avLst/>
-          </a:prstGeom>
-          <a:solidFill>
-            <a:srgbClr val="F4F6F7"/>
-          </a:solidFill>
-          <a:ln w="9525">
-            <a:solidFill>
-              <a:srgbClr val="D9DEE0"/>
-            </a:solidFill>
-          </a:ln>
-          <a:effectLst/>
-        </p:spPr>
-        <p:style>
-          <a:lnRef idx="1">
-            <a:schemeClr val="accent1"/>
-          </a:lnRef>
-          <a:fillRef idx="3">
-            <a:schemeClr val="accent1"/>
-          </a:fillRef>
-          <a:effectRef idx="2">
-            <a:schemeClr val="accent1"/>
-          </a:effectRef>
-          <a:fontRef idx="minor">
-            <a:schemeClr val="lt1"/>
-          </a:fontRef>
-        </p:style>
-        <p:txBody>
-          <a:bodyPr rtlCol="0" anchor="ctr"/>
-          <a:lstStyle/>
-          <a:p>
-            <a:pPr algn="ctr"/>
-          </a:p>
-        </p:txBody>
-      </p:sp>
-      <p:sp>
-        <p:nvSpPr>
-          <p:cNvPr id="12" name="Rectangle 11"/>
-          <p:cNvSpPr/>
-          <p:nvPr/>
-        </p:nvSpPr>
-        <p:spPr>
-          <a:xfrm>
-            <a:off x="6324447" y="1828800"/>
-            <a:ext cx="91440" cy="1143000"/>
-          </a:xfrm>
-          <a:prstGeom prst="rect">
-            <a:avLst/>
-          </a:prstGeom>
-          <a:solidFill>
-            <a:srgbClr val="3C7A8C"/>
-          </a:solidFill>
-          <a:ln>
-            <a:noFill/>
-          </a:ln>
-          <a:effectLst/>
-        </p:spPr>
-        <p:style>
-          <a:lnRef idx="1">
-            <a:schemeClr val="accent1"/>
-          </a:lnRef>
-          <a:fillRef idx="3">
-            <a:schemeClr val="accent1"/>
-          </a:fillRef>
-          <a:effectRef idx="2">
-            <a:schemeClr val="accent1"/>
-          </a:effectRef>
-          <a:fontRef idx="minor">
-            <a:schemeClr val="lt1"/>
-          </a:fontRef>
-        </p:style>
-        <p:txBody>
-          <a:bodyPr rtlCol="0" anchor="ctr"/>
-          <a:lstStyle/>
-          <a:p>
-            <a:pPr algn="ctr"/>
-          </a:p>
-        </p:txBody>
-      </p:sp>
-      <p:sp>
-        <p:nvSpPr>
-          <p:cNvPr id="13" name="TextBox 12"/>
-          <p:cNvSpPr txBox="1"/>
-          <p:nvPr/>
-        </p:nvSpPr>
-        <p:spPr>
-          <a:xfrm>
-            <a:off x="6598767" y="2029968"/>
-            <a:ext cx="4523079" cy="868680"/>
-          </a:xfrm>
-          <a:prstGeom prst="rect">
-            <a:avLst/>
-          </a:prstGeom>
-          <a:noFill/>
-        </p:spPr>
-        <p:txBody>
-          <a:bodyPr wrap="square" lIns="0" rIns="0" tIns="0" bIns="0">
-            <a:spAutoFit/>
-          </a:bodyPr>
-          <a:lstStyle/>
-          <a:p>
-            <a:pPr algn="l">
-              <a:spcBef>
-                <a:spcPts val="0"/>
-              </a:spcBef>
-              <a:spcAft>
-                <a:spcPts val="600"/>
-              </a:spcAft>
-            </a:pPr>
-            <a:r>
-              <a:rPr sz="1350" b="0" i="0">
-                <a:solidFill>
-                  <a:srgbClr val="2B2B2B"/>
-                </a:solidFill>
-                <a:latin typeface="Calibri"/>
-              </a:rPr>
-              <a:t>Coorte única e transversal (China, 2012) → fala de associação, não de causalidade.</a:t>
-            </a:r>
-          </a:p>
-        </p:txBody>
-      </p:sp>
-      <p:sp>
-        <p:nvSpPr>
-          <p:cNvPr id="14" name="Rectangle 13"/>
-          <p:cNvSpPr/>
-          <p:nvPr/>
-        </p:nvSpPr>
-        <p:spPr>
-          <a:xfrm>
-            <a:off x="841248" y="3154680"/>
-            <a:ext cx="5025999" cy="1143000"/>
-          </a:xfrm>
-          <a:prstGeom prst="rect">
-            <a:avLst/>
-          </a:prstGeom>
-          <a:solidFill>
-            <a:srgbClr val="F4F6F7"/>
-          </a:solidFill>
-          <a:ln w="9525">
-            <a:solidFill>
-              <a:srgbClr val="D9DEE0"/>
-            </a:solidFill>
-          </a:ln>
-          <a:effectLst/>
-        </p:spPr>
-        <p:style>
-          <a:lnRef idx="1">
-            <a:schemeClr val="accent1"/>
-          </a:lnRef>
-          <a:fillRef idx="3">
-            <a:schemeClr val="accent1"/>
-          </a:fillRef>
-          <a:effectRef idx="2">
-            <a:schemeClr val="accent1"/>
-          </a:effectRef>
-          <a:fontRef idx="minor">
-            <a:schemeClr val="lt1"/>
-          </a:fontRef>
-        </p:style>
-        <p:txBody>
-          <a:bodyPr rtlCol="0" anchor="ctr"/>
-          <a:lstStyle/>
-          <a:p>
-            <a:pPr algn="ctr"/>
-          </a:p>
-        </p:txBody>
-      </p:sp>
-      <p:sp>
-        <p:nvSpPr>
-          <p:cNvPr id="15" name="Rectangle 14"/>
-          <p:cNvSpPr/>
-          <p:nvPr/>
-        </p:nvSpPr>
-        <p:spPr>
-          <a:xfrm>
-            <a:off x="841248" y="3154680"/>
-            <a:ext cx="91440" cy="1143000"/>
-          </a:xfrm>
-          <a:prstGeom prst="rect">
-            <a:avLst/>
-          </a:prstGeom>
-          <a:solidFill>
-            <a:srgbClr val="3C7A8C"/>
-          </a:solidFill>
-          <a:ln>
-            <a:noFill/>
-          </a:ln>
-          <a:effectLst/>
-        </p:spPr>
-        <p:style>
-          <a:lnRef idx="1">
-            <a:schemeClr val="accent1"/>
-          </a:lnRef>
-          <a:fillRef idx="3">
-            <a:schemeClr val="accent1"/>
-          </a:fillRef>
-          <a:effectRef idx="2">
-            <a:schemeClr val="accent1"/>
-          </a:effectRef>
-          <a:fontRef idx="minor">
-            <a:schemeClr val="lt1"/>
-          </a:fontRef>
-        </p:style>
-        <p:txBody>
-          <a:bodyPr rtlCol="0" anchor="ctr"/>
-          <a:lstStyle/>
-          <a:p>
-            <a:pPr algn="ctr"/>
-          </a:p>
-        </p:txBody>
-      </p:sp>
-      <p:sp>
-        <p:nvSpPr>
-          <p:cNvPr id="16" name="TextBox 15"/>
-          <p:cNvSpPr txBox="1"/>
-          <p:nvPr/>
-        </p:nvSpPr>
-        <p:spPr>
-          <a:xfrm>
-            <a:off x="1115568" y="3355848"/>
-            <a:ext cx="4523079" cy="868680"/>
-          </a:xfrm>
-          <a:prstGeom prst="rect">
-            <a:avLst/>
-          </a:prstGeom>
-          <a:noFill/>
-        </p:spPr>
-        <p:txBody>
-          <a:bodyPr wrap="square" lIns="0" rIns="0" tIns="0" bIns="0">
-            <a:spAutoFit/>
-          </a:bodyPr>
-          <a:lstStyle/>
-          <a:p>
-            <a:pPr algn="l">
-              <a:spcBef>
-                <a:spcPts val="0"/>
-              </a:spcBef>
-              <a:spcAft>
-                <a:spcPts val="600"/>
-              </a:spcAft>
-            </a:pPr>
-            <a:r>
-              <a:rPr sz="1350" b="0" i="0">
-                <a:solidFill>
-                  <a:srgbClr val="2B2B2B"/>
-                </a:solidFill>
-                <a:latin typeface="Calibri"/>
-              </a:rPr>
-              <a:t>O rótulo 'ideal' é uma escolha de projeto defensável, não a única.</a:t>
-            </a:r>
-          </a:p>
-        </p:txBody>
-      </p:sp>
-      <p:sp>
-        <p:nvSpPr>
-          <p:cNvPr id="17" name="Rectangle 16"/>
-          <p:cNvSpPr/>
-          <p:nvPr/>
-        </p:nvSpPr>
-        <p:spPr>
-          <a:xfrm>
-            <a:off x="6324447" y="3154680"/>
-            <a:ext cx="5025999" cy="1143000"/>
-          </a:xfrm>
-          <a:prstGeom prst="rect">
-            <a:avLst/>
-          </a:prstGeom>
-          <a:solidFill>
-            <a:srgbClr val="F4F6F7"/>
-          </a:solidFill>
-          <a:ln w="9525">
-            <a:solidFill>
-              <a:srgbClr val="D9DEE0"/>
-            </a:solidFill>
-          </a:ln>
-          <a:effectLst/>
-        </p:spPr>
-        <p:style>
-          <a:lnRef idx="1">
-            <a:schemeClr val="accent1"/>
-          </a:lnRef>
-          <a:fillRef idx="3">
-            <a:schemeClr val="accent1"/>
-          </a:fillRef>
-          <a:effectRef idx="2">
-            <a:schemeClr val="accent1"/>
-          </a:effectRef>
-          <a:fontRef idx="minor">
-            <a:schemeClr val="lt1"/>
-          </a:fontRef>
-        </p:style>
-        <p:txBody>
-          <a:bodyPr rtlCol="0" anchor="ctr"/>
-          <a:lstStyle/>
-          <a:p>
-            <a:pPr algn="ctr"/>
-          </a:p>
-        </p:txBody>
-      </p:sp>
-      <p:sp>
-        <p:nvSpPr>
-          <p:cNvPr id="18" name="Rectangle 17"/>
-          <p:cNvSpPr/>
-          <p:nvPr/>
-        </p:nvSpPr>
-        <p:spPr>
-          <a:xfrm>
-            <a:off x="6324447" y="3154680"/>
-            <a:ext cx="91440" cy="1143000"/>
-          </a:xfrm>
-          <a:prstGeom prst="rect">
-            <a:avLst/>
-          </a:prstGeom>
-          <a:solidFill>
-            <a:srgbClr val="3C7A8C"/>
-          </a:solidFill>
-          <a:ln>
-            <a:noFill/>
-          </a:ln>
-          <a:effectLst/>
-        </p:spPr>
-        <p:style>
-          <a:lnRef idx="1">
-            <a:schemeClr val="accent1"/>
-          </a:lnRef>
-          <a:fillRef idx="3">
-            <a:schemeClr val="accent1"/>
-          </a:fillRef>
-          <a:effectRef idx="2">
-            <a:schemeClr val="accent1"/>
-          </a:effectRef>
-          <a:fontRef idx="minor">
-            <a:schemeClr val="lt1"/>
-          </a:fontRef>
-        </p:style>
-        <p:txBody>
-          <a:bodyPr rtlCol="0" anchor="ctr"/>
-          <a:lstStyle/>
-          <a:p>
-            <a:pPr algn="ctr"/>
-          </a:p>
-        </p:txBody>
-      </p:sp>
-      <p:sp>
-        <p:nvSpPr>
-          <p:cNvPr id="19" name="TextBox 18"/>
-          <p:cNvSpPr txBox="1"/>
-          <p:nvPr/>
-        </p:nvSpPr>
-        <p:spPr>
-          <a:xfrm>
-            <a:off x="6598767" y="3355848"/>
-            <a:ext cx="4523079" cy="868680"/>
-          </a:xfrm>
-          <a:prstGeom prst="rect">
-            <a:avLst/>
-          </a:prstGeom>
-          <a:noFill/>
-        </p:spPr>
-        <p:txBody>
-          <a:bodyPr wrap="square" lIns="0" rIns="0" tIns="0" bIns="0">
-            <a:spAutoFit/>
-          </a:bodyPr>
-          <a:lstStyle/>
-          <a:p>
-            <a:pPr algn="l">
-              <a:spcBef>
-                <a:spcPts val="0"/>
-              </a:spcBef>
-              <a:spcAft>
-                <a:spcPts val="600"/>
-              </a:spcAft>
-            </a:pPr>
-            <a:r>
-              <a:rPr sz="1350" b="0" i="0">
-                <a:solidFill>
-                  <a:srgbClr val="2B2B2B"/>
-                </a:solidFill>
-                <a:latin typeface="Calibri"/>
-              </a:rPr>
-              <a:t>As 26 preditoras foram curadas à mão → podem ter omitido pistas relevantes.</a:t>
-            </a:r>
-          </a:p>
-        </p:txBody>
-      </p:sp>
-      <p:sp>
-        <p:nvSpPr>
-          <p:cNvPr id="20" name="Rectangle 19"/>
-          <p:cNvSpPr/>
-          <p:nvPr/>
-        </p:nvSpPr>
-        <p:spPr>
-          <a:xfrm>
-            <a:off x="841248" y="4480560"/>
-            <a:ext cx="5025999" cy="1143000"/>
-          </a:xfrm>
-          <a:prstGeom prst="rect">
-            <a:avLst/>
-          </a:prstGeom>
-          <a:solidFill>
-            <a:srgbClr val="F4F6F7"/>
-          </a:solidFill>
-          <a:ln w="9525">
-            <a:solidFill>
-              <a:srgbClr val="D9DEE0"/>
-            </a:solidFill>
-          </a:ln>
-          <a:effectLst/>
-        </p:spPr>
-        <p:style>
-          <a:lnRef idx="1">
-            <a:schemeClr val="accent1"/>
-          </a:lnRef>
-          <a:fillRef idx="3">
-            <a:schemeClr val="accent1"/>
-          </a:fillRef>
-          <a:effectRef idx="2">
-            <a:schemeClr val="accent1"/>
-          </a:effectRef>
-          <a:fontRef idx="minor">
-            <a:schemeClr val="lt1"/>
-          </a:fontRef>
-        </p:style>
-        <p:txBody>
-          <a:bodyPr rtlCol="0" anchor="ctr"/>
-          <a:lstStyle/>
-          <a:p>
-            <a:pPr algn="ctr"/>
-          </a:p>
-        </p:txBody>
-      </p:sp>
-      <p:sp>
-        <p:nvSpPr>
-          <p:cNvPr id="21" name="Rectangle 20"/>
-          <p:cNvSpPr/>
-          <p:nvPr/>
-        </p:nvSpPr>
-        <p:spPr>
-          <a:xfrm>
-            <a:off x="841248" y="4480560"/>
-            <a:ext cx="91440" cy="1143000"/>
-          </a:xfrm>
-          <a:prstGeom prst="rect">
-            <a:avLst/>
-          </a:prstGeom>
-          <a:solidFill>
-            <a:srgbClr val="3C7A8C"/>
-          </a:solidFill>
-          <a:ln>
-            <a:noFill/>
-          </a:ln>
-          <a:effectLst/>
-        </p:spPr>
-        <p:style>
-          <a:lnRef idx="1">
-            <a:schemeClr val="accent1"/>
-          </a:lnRef>
-          <a:fillRef idx="3">
-            <a:schemeClr val="accent1"/>
-          </a:fillRef>
-          <a:effectRef idx="2">
-            <a:schemeClr val="accent1"/>
-          </a:effectRef>
-          <a:fontRef idx="minor">
-            <a:schemeClr val="lt1"/>
-          </a:fontRef>
-        </p:style>
-        <p:txBody>
-          <a:bodyPr rtlCol="0" anchor="ctr"/>
-          <a:lstStyle/>
-          <a:p>
-            <a:pPr algn="ctr"/>
-          </a:p>
-        </p:txBody>
-      </p:sp>
-      <p:sp>
-        <p:nvSpPr>
-          <p:cNvPr id="22" name="TextBox 21"/>
-          <p:cNvSpPr txBox="1"/>
-          <p:nvPr/>
-        </p:nvSpPr>
-        <p:spPr>
-          <a:xfrm>
-            <a:off x="1115568" y="4681728"/>
-            <a:ext cx="4523079" cy="868680"/>
-          </a:xfrm>
-          <a:prstGeom prst="rect">
-            <a:avLst/>
-          </a:prstGeom>
-          <a:noFill/>
-        </p:spPr>
-        <p:txBody>
-          <a:bodyPr wrap="square" lIns="0" rIns="0" tIns="0" bIns="0">
-            <a:spAutoFit/>
-          </a:bodyPr>
-          <a:lstStyle/>
-          <a:p>
-            <a:pPr algn="l">
-              <a:spcBef>
-                <a:spcPts val="0"/>
-              </a:spcBef>
-              <a:spcAft>
-                <a:spcPts val="600"/>
-              </a:spcAft>
-            </a:pPr>
-            <a:r>
-              <a:rPr sz="1350" b="0" i="0">
-                <a:solidFill>
-                  <a:srgbClr val="2B2B2B"/>
-                </a:solidFill>
-                <a:latin typeface="Calibri"/>
-              </a:rPr>
-              <a:t>Imputação pela mediana 'achata' a variação; o corte do terço (33%) é limiar arbitrário.</a:t>
-            </a:r>
-          </a:p>
-        </p:txBody>
-      </p:sp>
-      <p:sp>
-        <p:nvSpPr>
-          <p:cNvPr id="23" name="Rectangle 22"/>
-          <p:cNvSpPr/>
-          <p:nvPr/>
-        </p:nvSpPr>
-        <p:spPr>
-          <a:xfrm>
-            <a:off x="6324447" y="4480560"/>
-            <a:ext cx="5025999" cy="1143000"/>
-          </a:xfrm>
-          <a:prstGeom prst="rect">
-            <a:avLst/>
-          </a:prstGeom>
-          <a:solidFill>
-            <a:srgbClr val="F4F6F7"/>
-          </a:solidFill>
-          <a:ln w="9525">
-            <a:solidFill>
-              <a:srgbClr val="D9DEE0"/>
-            </a:solidFill>
-          </a:ln>
-          <a:effectLst/>
-        </p:spPr>
-        <p:style>
-          <a:lnRef idx="1">
-            <a:schemeClr val="accent1"/>
-          </a:lnRef>
-          <a:fillRef idx="3">
-            <a:schemeClr val="accent1"/>
-          </a:fillRef>
-          <a:effectRef idx="2">
-            <a:schemeClr val="accent1"/>
-          </a:effectRef>
-          <a:fontRef idx="minor">
-            <a:schemeClr val="lt1"/>
-          </a:fontRef>
-        </p:style>
-        <p:txBody>
-          <a:bodyPr rtlCol="0" anchor="ctr"/>
-          <a:lstStyle/>
-          <a:p>
-            <a:pPr algn="ctr"/>
-          </a:p>
-        </p:txBody>
-      </p:sp>
-      <p:sp>
-        <p:nvSpPr>
-          <p:cNvPr id="24" name="Rectangle 23"/>
-          <p:cNvSpPr/>
-          <p:nvPr/>
-        </p:nvSpPr>
-        <p:spPr>
-          <a:xfrm>
-            <a:off x="6324447" y="4480560"/>
-            <a:ext cx="91440" cy="1143000"/>
-          </a:xfrm>
-          <a:prstGeom prst="rect">
-            <a:avLst/>
-          </a:prstGeom>
-          <a:solidFill>
-            <a:srgbClr val="3C7A8C"/>
-          </a:solidFill>
-          <a:ln>
-            <a:noFill/>
-          </a:ln>
-          <a:effectLst/>
-        </p:spPr>
-        <p:style>
-          <a:lnRef idx="1">
-            <a:schemeClr val="accent1"/>
-          </a:lnRef>
-          <a:fillRef idx="3">
-            <a:schemeClr val="accent1"/>
-          </a:fillRef>
-          <a:effectRef idx="2">
-            <a:schemeClr val="accent1"/>
-          </a:effectRef>
-          <a:fontRef idx="minor">
-            <a:schemeClr val="lt1"/>
-          </a:fontRef>
-        </p:style>
-        <p:txBody>
-          <a:bodyPr rtlCol="0" anchor="ctr"/>
-          <a:lstStyle/>
-          <a:p>
-            <a:pPr algn="ctr"/>
-          </a:p>
-        </p:txBody>
-      </p:sp>
-      <p:sp>
-        <p:nvSpPr>
-          <p:cNvPr id="25" name="TextBox 24"/>
-          <p:cNvSpPr txBox="1"/>
-          <p:nvPr/>
-        </p:nvSpPr>
-        <p:spPr>
-          <a:xfrm>
-            <a:off x="6598767" y="4681728"/>
-            <a:ext cx="4523079" cy="868680"/>
-          </a:xfrm>
-          <a:prstGeom prst="rect">
-            <a:avLst/>
-          </a:prstGeom>
-          <a:noFill/>
-        </p:spPr>
-        <p:txBody>
-          <a:bodyPr wrap="square" lIns="0" rIns="0" tIns="0" bIns="0">
-            <a:spAutoFit/>
-          </a:bodyPr>
-          <a:lstStyle/>
-          <a:p>
-            <a:pPr algn="l">
-              <a:spcBef>
-                <a:spcPts val="0"/>
-              </a:spcBef>
-              <a:spcAft>
-                <a:spcPts val="600"/>
-              </a:spcAft>
-            </a:pPr>
-            <a:r>
-              <a:rPr sz="1350" b="0" i="0">
-                <a:solidFill>
-                  <a:srgbClr val="2B2B2B"/>
-                </a:solidFill>
-                <a:latin typeface="Calibri"/>
-              </a:rPr>
-              <a:t>L2 (λ=0,05) calibrado empiricamente, não por cross-validation formal.</a:t>
+              <a:t>Recuperou 8 de 9 marcadores plantados; o subconjunto selecionado eleva o R².</a:t>
             </a:r>
           </a:p>
         </p:txBody>
@@ -6734,7 +6796,7 @@
                 </a:solidFill>
                 <a:latin typeface="Cambria"/>
               </a:rPr>
-              <a:t>Próximos passos e conclusão</a:t>
+              <a:t>Limitações declaradas</a:t>
             </a:r>
           </a:p>
         </p:txBody>
@@ -6862,7 +6924,1073 @@
                 </a:solidFill>
                 <a:latin typeface="Calibri"/>
               </a:rPr>
-              <a:t>13 / 13</a:t>
+              <a:t>13 / 14</a:t>
+            </a:r>
+          </a:p>
+        </p:txBody>
+      </p:sp>
+      <p:sp>
+        <p:nvSpPr>
+          <p:cNvPr id="8" name="Rectangle 7"/>
+          <p:cNvSpPr/>
+          <p:nvPr/>
+        </p:nvSpPr>
+        <p:spPr>
+          <a:xfrm>
+            <a:off x="841248" y="1828800"/>
+            <a:ext cx="5025999" cy="1143000"/>
+          </a:xfrm>
+          <a:prstGeom prst="rect">
+            <a:avLst/>
+          </a:prstGeom>
+          <a:solidFill>
+            <a:srgbClr val="F4F6F7"/>
+          </a:solidFill>
+          <a:ln w="9525">
+            <a:solidFill>
+              <a:srgbClr val="D9DEE0"/>
+            </a:solidFill>
+          </a:ln>
+          <a:effectLst/>
+        </p:spPr>
+        <p:style>
+          <a:lnRef idx="1">
+            <a:schemeClr val="accent1"/>
+          </a:lnRef>
+          <a:fillRef idx="3">
+            <a:schemeClr val="accent1"/>
+          </a:fillRef>
+          <a:effectRef idx="2">
+            <a:schemeClr val="accent1"/>
+          </a:effectRef>
+          <a:fontRef idx="minor">
+            <a:schemeClr val="lt1"/>
+          </a:fontRef>
+        </p:style>
+        <p:txBody>
+          <a:bodyPr rtlCol="0" anchor="ctr"/>
+          <a:lstStyle/>
+          <a:p>
+            <a:pPr algn="ctr"/>
+          </a:p>
+        </p:txBody>
+      </p:sp>
+      <p:sp>
+        <p:nvSpPr>
+          <p:cNvPr id="9" name="Rectangle 8"/>
+          <p:cNvSpPr/>
+          <p:nvPr/>
+        </p:nvSpPr>
+        <p:spPr>
+          <a:xfrm>
+            <a:off x="841248" y="1828800"/>
+            <a:ext cx="91440" cy="1143000"/>
+          </a:xfrm>
+          <a:prstGeom prst="rect">
+            <a:avLst/>
+          </a:prstGeom>
+          <a:solidFill>
+            <a:srgbClr val="3C7A8C"/>
+          </a:solidFill>
+          <a:ln>
+            <a:noFill/>
+          </a:ln>
+          <a:effectLst/>
+        </p:spPr>
+        <p:style>
+          <a:lnRef idx="1">
+            <a:schemeClr val="accent1"/>
+          </a:lnRef>
+          <a:fillRef idx="3">
+            <a:schemeClr val="accent1"/>
+          </a:fillRef>
+          <a:effectRef idx="2">
+            <a:schemeClr val="accent1"/>
+          </a:effectRef>
+          <a:fontRef idx="minor">
+            <a:schemeClr val="lt1"/>
+          </a:fontRef>
+        </p:style>
+        <p:txBody>
+          <a:bodyPr rtlCol="0" anchor="ctr"/>
+          <a:lstStyle/>
+          <a:p>
+            <a:pPr algn="ctr"/>
+          </a:p>
+        </p:txBody>
+      </p:sp>
+      <p:sp>
+        <p:nvSpPr>
+          <p:cNvPr id="10" name="TextBox 9"/>
+          <p:cNvSpPr txBox="1"/>
+          <p:nvPr/>
+        </p:nvSpPr>
+        <p:spPr>
+          <a:xfrm>
+            <a:off x="1115568" y="2029968"/>
+            <a:ext cx="4523079" cy="868680"/>
+          </a:xfrm>
+          <a:prstGeom prst="rect">
+            <a:avLst/>
+          </a:prstGeom>
+          <a:noFill/>
+        </p:spPr>
+        <p:txBody>
+          <a:bodyPr wrap="square" lIns="0" rIns="0" tIns="0" bIns="0">
+            <a:spAutoFit/>
+          </a:bodyPr>
+          <a:lstStyle/>
+          <a:p>
+            <a:pPr algn="l">
+              <a:spcBef>
+                <a:spcPts val="0"/>
+              </a:spcBef>
+              <a:spcAft>
+                <a:spcPts val="600"/>
+              </a:spcAft>
+            </a:pPr>
+            <a:r>
+              <a:rPr sz="1350" b="0" i="0">
+                <a:solidFill>
+                  <a:srgbClr val="2B2B2B"/>
+                </a:solidFill>
+                <a:latin typeface="Calibri"/>
+              </a:rPr>
+              <a:t>A base não distingue T1D/T2D → 'diabetes tipo não especificado'; é testbed, não evidência clínica.</a:t>
+            </a:r>
+          </a:p>
+        </p:txBody>
+      </p:sp>
+      <p:sp>
+        <p:nvSpPr>
+          <p:cNvPr id="11" name="Rectangle 10"/>
+          <p:cNvSpPr/>
+          <p:nvPr/>
+        </p:nvSpPr>
+        <p:spPr>
+          <a:xfrm>
+            <a:off x="6324447" y="1828800"/>
+            <a:ext cx="5025999" cy="1143000"/>
+          </a:xfrm>
+          <a:prstGeom prst="rect">
+            <a:avLst/>
+          </a:prstGeom>
+          <a:solidFill>
+            <a:srgbClr val="F4F6F7"/>
+          </a:solidFill>
+          <a:ln w="9525">
+            <a:solidFill>
+              <a:srgbClr val="D9DEE0"/>
+            </a:solidFill>
+          </a:ln>
+          <a:effectLst/>
+        </p:spPr>
+        <p:style>
+          <a:lnRef idx="1">
+            <a:schemeClr val="accent1"/>
+          </a:lnRef>
+          <a:fillRef idx="3">
+            <a:schemeClr val="accent1"/>
+          </a:fillRef>
+          <a:effectRef idx="2">
+            <a:schemeClr val="accent1"/>
+          </a:effectRef>
+          <a:fontRef idx="minor">
+            <a:schemeClr val="lt1"/>
+          </a:fontRef>
+        </p:style>
+        <p:txBody>
+          <a:bodyPr rtlCol="0" anchor="ctr"/>
+          <a:lstStyle/>
+          <a:p>
+            <a:pPr algn="ctr"/>
+          </a:p>
+        </p:txBody>
+      </p:sp>
+      <p:sp>
+        <p:nvSpPr>
+          <p:cNvPr id="12" name="Rectangle 11"/>
+          <p:cNvSpPr/>
+          <p:nvPr/>
+        </p:nvSpPr>
+        <p:spPr>
+          <a:xfrm>
+            <a:off x="6324447" y="1828800"/>
+            <a:ext cx="91440" cy="1143000"/>
+          </a:xfrm>
+          <a:prstGeom prst="rect">
+            <a:avLst/>
+          </a:prstGeom>
+          <a:solidFill>
+            <a:srgbClr val="3C7A8C"/>
+          </a:solidFill>
+          <a:ln>
+            <a:noFill/>
+          </a:ln>
+          <a:effectLst/>
+        </p:spPr>
+        <p:style>
+          <a:lnRef idx="1">
+            <a:schemeClr val="accent1"/>
+          </a:lnRef>
+          <a:fillRef idx="3">
+            <a:schemeClr val="accent1"/>
+          </a:fillRef>
+          <a:effectRef idx="2">
+            <a:schemeClr val="accent1"/>
+          </a:effectRef>
+          <a:fontRef idx="minor">
+            <a:schemeClr val="lt1"/>
+          </a:fontRef>
+        </p:style>
+        <p:txBody>
+          <a:bodyPr rtlCol="0" anchor="ctr"/>
+          <a:lstStyle/>
+          <a:p>
+            <a:pPr algn="ctr"/>
+          </a:p>
+        </p:txBody>
+      </p:sp>
+      <p:sp>
+        <p:nvSpPr>
+          <p:cNvPr id="13" name="TextBox 12"/>
+          <p:cNvSpPr txBox="1"/>
+          <p:nvPr/>
+        </p:nvSpPr>
+        <p:spPr>
+          <a:xfrm>
+            <a:off x="6598767" y="2029968"/>
+            <a:ext cx="4523079" cy="868680"/>
+          </a:xfrm>
+          <a:prstGeom prst="rect">
+            <a:avLst/>
+          </a:prstGeom>
+          <a:noFill/>
+        </p:spPr>
+        <p:txBody>
+          <a:bodyPr wrap="square" lIns="0" rIns="0" tIns="0" bIns="0">
+            <a:spAutoFit/>
+          </a:bodyPr>
+          <a:lstStyle/>
+          <a:p>
+            <a:pPr algn="l">
+              <a:spcBef>
+                <a:spcPts val="0"/>
+              </a:spcBef>
+              <a:spcAft>
+                <a:spcPts val="600"/>
+              </a:spcAft>
+            </a:pPr>
+            <a:r>
+              <a:rPr sz="1350" b="0" i="0">
+                <a:solidFill>
+                  <a:srgbClr val="2B2B2B"/>
+                </a:solidFill>
+                <a:latin typeface="Calibri"/>
+              </a:rPr>
+              <a:t>Coorte única e transversal (China, 2012) → fala de associação, não de causalidade.</a:t>
+            </a:r>
+          </a:p>
+        </p:txBody>
+      </p:sp>
+      <p:sp>
+        <p:nvSpPr>
+          <p:cNvPr id="14" name="Rectangle 13"/>
+          <p:cNvSpPr/>
+          <p:nvPr/>
+        </p:nvSpPr>
+        <p:spPr>
+          <a:xfrm>
+            <a:off x="841248" y="3154680"/>
+            <a:ext cx="5025999" cy="1143000"/>
+          </a:xfrm>
+          <a:prstGeom prst="rect">
+            <a:avLst/>
+          </a:prstGeom>
+          <a:solidFill>
+            <a:srgbClr val="F4F6F7"/>
+          </a:solidFill>
+          <a:ln w="9525">
+            <a:solidFill>
+              <a:srgbClr val="D9DEE0"/>
+            </a:solidFill>
+          </a:ln>
+          <a:effectLst/>
+        </p:spPr>
+        <p:style>
+          <a:lnRef idx="1">
+            <a:schemeClr val="accent1"/>
+          </a:lnRef>
+          <a:fillRef idx="3">
+            <a:schemeClr val="accent1"/>
+          </a:fillRef>
+          <a:effectRef idx="2">
+            <a:schemeClr val="accent1"/>
+          </a:effectRef>
+          <a:fontRef idx="minor">
+            <a:schemeClr val="lt1"/>
+          </a:fontRef>
+        </p:style>
+        <p:txBody>
+          <a:bodyPr rtlCol="0" anchor="ctr"/>
+          <a:lstStyle/>
+          <a:p>
+            <a:pPr algn="ctr"/>
+          </a:p>
+        </p:txBody>
+      </p:sp>
+      <p:sp>
+        <p:nvSpPr>
+          <p:cNvPr id="15" name="Rectangle 14"/>
+          <p:cNvSpPr/>
+          <p:nvPr/>
+        </p:nvSpPr>
+        <p:spPr>
+          <a:xfrm>
+            <a:off x="841248" y="3154680"/>
+            <a:ext cx="91440" cy="1143000"/>
+          </a:xfrm>
+          <a:prstGeom prst="rect">
+            <a:avLst/>
+          </a:prstGeom>
+          <a:solidFill>
+            <a:srgbClr val="3C7A8C"/>
+          </a:solidFill>
+          <a:ln>
+            <a:noFill/>
+          </a:ln>
+          <a:effectLst/>
+        </p:spPr>
+        <p:style>
+          <a:lnRef idx="1">
+            <a:schemeClr val="accent1"/>
+          </a:lnRef>
+          <a:fillRef idx="3">
+            <a:schemeClr val="accent1"/>
+          </a:fillRef>
+          <a:effectRef idx="2">
+            <a:schemeClr val="accent1"/>
+          </a:effectRef>
+          <a:fontRef idx="minor">
+            <a:schemeClr val="lt1"/>
+          </a:fontRef>
+        </p:style>
+        <p:txBody>
+          <a:bodyPr rtlCol="0" anchor="ctr"/>
+          <a:lstStyle/>
+          <a:p>
+            <a:pPr algn="ctr"/>
+          </a:p>
+        </p:txBody>
+      </p:sp>
+      <p:sp>
+        <p:nvSpPr>
+          <p:cNvPr id="16" name="TextBox 15"/>
+          <p:cNvSpPr txBox="1"/>
+          <p:nvPr/>
+        </p:nvSpPr>
+        <p:spPr>
+          <a:xfrm>
+            <a:off x="1115568" y="3355848"/>
+            <a:ext cx="4523079" cy="868680"/>
+          </a:xfrm>
+          <a:prstGeom prst="rect">
+            <a:avLst/>
+          </a:prstGeom>
+          <a:noFill/>
+        </p:spPr>
+        <p:txBody>
+          <a:bodyPr wrap="square" lIns="0" rIns="0" tIns="0" bIns="0">
+            <a:spAutoFit/>
+          </a:bodyPr>
+          <a:lstStyle/>
+          <a:p>
+            <a:pPr algn="l">
+              <a:spcBef>
+                <a:spcPts val="0"/>
+              </a:spcBef>
+              <a:spcAft>
+                <a:spcPts val="600"/>
+              </a:spcAft>
+            </a:pPr>
+            <a:r>
+              <a:rPr sz="1350" b="0" i="0">
+                <a:solidFill>
+                  <a:srgbClr val="2B2B2B"/>
+                </a:solidFill>
+                <a:latin typeface="Calibri"/>
+              </a:rPr>
+              <a:t>O rótulo 'ideal' é uma escolha de projeto defensável, não a única.</a:t>
+            </a:r>
+          </a:p>
+        </p:txBody>
+      </p:sp>
+      <p:sp>
+        <p:nvSpPr>
+          <p:cNvPr id="17" name="Rectangle 16"/>
+          <p:cNvSpPr/>
+          <p:nvPr/>
+        </p:nvSpPr>
+        <p:spPr>
+          <a:xfrm>
+            <a:off x="6324447" y="3154680"/>
+            <a:ext cx="5025999" cy="1143000"/>
+          </a:xfrm>
+          <a:prstGeom prst="rect">
+            <a:avLst/>
+          </a:prstGeom>
+          <a:solidFill>
+            <a:srgbClr val="F4F6F7"/>
+          </a:solidFill>
+          <a:ln w="9525">
+            <a:solidFill>
+              <a:srgbClr val="D9DEE0"/>
+            </a:solidFill>
+          </a:ln>
+          <a:effectLst/>
+        </p:spPr>
+        <p:style>
+          <a:lnRef idx="1">
+            <a:schemeClr val="accent1"/>
+          </a:lnRef>
+          <a:fillRef idx="3">
+            <a:schemeClr val="accent1"/>
+          </a:fillRef>
+          <a:effectRef idx="2">
+            <a:schemeClr val="accent1"/>
+          </a:effectRef>
+          <a:fontRef idx="minor">
+            <a:schemeClr val="lt1"/>
+          </a:fontRef>
+        </p:style>
+        <p:txBody>
+          <a:bodyPr rtlCol="0" anchor="ctr"/>
+          <a:lstStyle/>
+          <a:p>
+            <a:pPr algn="ctr"/>
+          </a:p>
+        </p:txBody>
+      </p:sp>
+      <p:sp>
+        <p:nvSpPr>
+          <p:cNvPr id="18" name="Rectangle 17"/>
+          <p:cNvSpPr/>
+          <p:nvPr/>
+        </p:nvSpPr>
+        <p:spPr>
+          <a:xfrm>
+            <a:off x="6324447" y="3154680"/>
+            <a:ext cx="91440" cy="1143000"/>
+          </a:xfrm>
+          <a:prstGeom prst="rect">
+            <a:avLst/>
+          </a:prstGeom>
+          <a:solidFill>
+            <a:srgbClr val="3C7A8C"/>
+          </a:solidFill>
+          <a:ln>
+            <a:noFill/>
+          </a:ln>
+          <a:effectLst/>
+        </p:spPr>
+        <p:style>
+          <a:lnRef idx="1">
+            <a:schemeClr val="accent1"/>
+          </a:lnRef>
+          <a:fillRef idx="3">
+            <a:schemeClr val="accent1"/>
+          </a:fillRef>
+          <a:effectRef idx="2">
+            <a:schemeClr val="accent1"/>
+          </a:effectRef>
+          <a:fontRef idx="minor">
+            <a:schemeClr val="lt1"/>
+          </a:fontRef>
+        </p:style>
+        <p:txBody>
+          <a:bodyPr rtlCol="0" anchor="ctr"/>
+          <a:lstStyle/>
+          <a:p>
+            <a:pPr algn="ctr"/>
+          </a:p>
+        </p:txBody>
+      </p:sp>
+      <p:sp>
+        <p:nvSpPr>
+          <p:cNvPr id="19" name="TextBox 18"/>
+          <p:cNvSpPr txBox="1"/>
+          <p:nvPr/>
+        </p:nvSpPr>
+        <p:spPr>
+          <a:xfrm>
+            <a:off x="6598767" y="3355848"/>
+            <a:ext cx="4523079" cy="868680"/>
+          </a:xfrm>
+          <a:prstGeom prst="rect">
+            <a:avLst/>
+          </a:prstGeom>
+          <a:noFill/>
+        </p:spPr>
+        <p:txBody>
+          <a:bodyPr wrap="square" lIns="0" rIns="0" tIns="0" bIns="0">
+            <a:spAutoFit/>
+          </a:bodyPr>
+          <a:lstStyle/>
+          <a:p>
+            <a:pPr algn="l">
+              <a:spcBef>
+                <a:spcPts val="0"/>
+              </a:spcBef>
+              <a:spcAft>
+                <a:spcPts val="600"/>
+              </a:spcAft>
+            </a:pPr>
+            <a:r>
+              <a:rPr sz="1350" b="0" i="0">
+                <a:solidFill>
+                  <a:srgbClr val="2B2B2B"/>
+                </a:solidFill>
+                <a:latin typeface="Calibri"/>
+              </a:rPr>
+              <a:t>As 26 preditoras foram curadas à mão → podem ter omitido pistas relevantes.</a:t>
+            </a:r>
+          </a:p>
+        </p:txBody>
+      </p:sp>
+      <p:sp>
+        <p:nvSpPr>
+          <p:cNvPr id="20" name="Rectangle 19"/>
+          <p:cNvSpPr/>
+          <p:nvPr/>
+        </p:nvSpPr>
+        <p:spPr>
+          <a:xfrm>
+            <a:off x="841248" y="4480560"/>
+            <a:ext cx="5025999" cy="1143000"/>
+          </a:xfrm>
+          <a:prstGeom prst="rect">
+            <a:avLst/>
+          </a:prstGeom>
+          <a:solidFill>
+            <a:srgbClr val="F4F6F7"/>
+          </a:solidFill>
+          <a:ln w="9525">
+            <a:solidFill>
+              <a:srgbClr val="D9DEE0"/>
+            </a:solidFill>
+          </a:ln>
+          <a:effectLst/>
+        </p:spPr>
+        <p:style>
+          <a:lnRef idx="1">
+            <a:schemeClr val="accent1"/>
+          </a:lnRef>
+          <a:fillRef idx="3">
+            <a:schemeClr val="accent1"/>
+          </a:fillRef>
+          <a:effectRef idx="2">
+            <a:schemeClr val="accent1"/>
+          </a:effectRef>
+          <a:fontRef idx="minor">
+            <a:schemeClr val="lt1"/>
+          </a:fontRef>
+        </p:style>
+        <p:txBody>
+          <a:bodyPr rtlCol="0" anchor="ctr"/>
+          <a:lstStyle/>
+          <a:p>
+            <a:pPr algn="ctr"/>
+          </a:p>
+        </p:txBody>
+      </p:sp>
+      <p:sp>
+        <p:nvSpPr>
+          <p:cNvPr id="21" name="Rectangle 20"/>
+          <p:cNvSpPr/>
+          <p:nvPr/>
+        </p:nvSpPr>
+        <p:spPr>
+          <a:xfrm>
+            <a:off x="841248" y="4480560"/>
+            <a:ext cx="91440" cy="1143000"/>
+          </a:xfrm>
+          <a:prstGeom prst="rect">
+            <a:avLst/>
+          </a:prstGeom>
+          <a:solidFill>
+            <a:srgbClr val="3C7A8C"/>
+          </a:solidFill>
+          <a:ln>
+            <a:noFill/>
+          </a:ln>
+          <a:effectLst/>
+        </p:spPr>
+        <p:style>
+          <a:lnRef idx="1">
+            <a:schemeClr val="accent1"/>
+          </a:lnRef>
+          <a:fillRef idx="3">
+            <a:schemeClr val="accent1"/>
+          </a:fillRef>
+          <a:effectRef idx="2">
+            <a:schemeClr val="accent1"/>
+          </a:effectRef>
+          <a:fontRef idx="minor">
+            <a:schemeClr val="lt1"/>
+          </a:fontRef>
+        </p:style>
+        <p:txBody>
+          <a:bodyPr rtlCol="0" anchor="ctr"/>
+          <a:lstStyle/>
+          <a:p>
+            <a:pPr algn="ctr"/>
+          </a:p>
+        </p:txBody>
+      </p:sp>
+      <p:sp>
+        <p:nvSpPr>
+          <p:cNvPr id="22" name="TextBox 21"/>
+          <p:cNvSpPr txBox="1"/>
+          <p:nvPr/>
+        </p:nvSpPr>
+        <p:spPr>
+          <a:xfrm>
+            <a:off x="1115568" y="4681728"/>
+            <a:ext cx="4523079" cy="868680"/>
+          </a:xfrm>
+          <a:prstGeom prst="rect">
+            <a:avLst/>
+          </a:prstGeom>
+          <a:noFill/>
+        </p:spPr>
+        <p:txBody>
+          <a:bodyPr wrap="square" lIns="0" rIns="0" tIns="0" bIns="0">
+            <a:spAutoFit/>
+          </a:bodyPr>
+          <a:lstStyle/>
+          <a:p>
+            <a:pPr algn="l">
+              <a:spcBef>
+                <a:spcPts val="0"/>
+              </a:spcBef>
+              <a:spcAft>
+                <a:spcPts val="600"/>
+              </a:spcAft>
+            </a:pPr>
+            <a:r>
+              <a:rPr sz="1350" b="0" i="0">
+                <a:solidFill>
+                  <a:srgbClr val="2B2B2B"/>
+                </a:solidFill>
+                <a:latin typeface="Calibri"/>
+              </a:rPr>
+              <a:t>Imputação pela mediana 'achata' a variação; o corte do terço (33%) é limiar arbitrário.</a:t>
+            </a:r>
+          </a:p>
+        </p:txBody>
+      </p:sp>
+      <p:sp>
+        <p:nvSpPr>
+          <p:cNvPr id="23" name="Rectangle 22"/>
+          <p:cNvSpPr/>
+          <p:nvPr/>
+        </p:nvSpPr>
+        <p:spPr>
+          <a:xfrm>
+            <a:off x="6324447" y="4480560"/>
+            <a:ext cx="5025999" cy="1143000"/>
+          </a:xfrm>
+          <a:prstGeom prst="rect">
+            <a:avLst/>
+          </a:prstGeom>
+          <a:solidFill>
+            <a:srgbClr val="F4F6F7"/>
+          </a:solidFill>
+          <a:ln w="9525">
+            <a:solidFill>
+              <a:srgbClr val="D9DEE0"/>
+            </a:solidFill>
+          </a:ln>
+          <a:effectLst/>
+        </p:spPr>
+        <p:style>
+          <a:lnRef idx="1">
+            <a:schemeClr val="accent1"/>
+          </a:lnRef>
+          <a:fillRef idx="3">
+            <a:schemeClr val="accent1"/>
+          </a:fillRef>
+          <a:effectRef idx="2">
+            <a:schemeClr val="accent1"/>
+          </a:effectRef>
+          <a:fontRef idx="minor">
+            <a:schemeClr val="lt1"/>
+          </a:fontRef>
+        </p:style>
+        <p:txBody>
+          <a:bodyPr rtlCol="0" anchor="ctr"/>
+          <a:lstStyle/>
+          <a:p>
+            <a:pPr algn="ctr"/>
+          </a:p>
+        </p:txBody>
+      </p:sp>
+      <p:sp>
+        <p:nvSpPr>
+          <p:cNvPr id="24" name="Rectangle 23"/>
+          <p:cNvSpPr/>
+          <p:nvPr/>
+        </p:nvSpPr>
+        <p:spPr>
+          <a:xfrm>
+            <a:off x="6324447" y="4480560"/>
+            <a:ext cx="91440" cy="1143000"/>
+          </a:xfrm>
+          <a:prstGeom prst="rect">
+            <a:avLst/>
+          </a:prstGeom>
+          <a:solidFill>
+            <a:srgbClr val="3C7A8C"/>
+          </a:solidFill>
+          <a:ln>
+            <a:noFill/>
+          </a:ln>
+          <a:effectLst/>
+        </p:spPr>
+        <p:style>
+          <a:lnRef idx="1">
+            <a:schemeClr val="accent1"/>
+          </a:lnRef>
+          <a:fillRef idx="3">
+            <a:schemeClr val="accent1"/>
+          </a:fillRef>
+          <a:effectRef idx="2">
+            <a:schemeClr val="accent1"/>
+          </a:effectRef>
+          <a:fontRef idx="minor">
+            <a:schemeClr val="lt1"/>
+          </a:fontRef>
+        </p:style>
+        <p:txBody>
+          <a:bodyPr rtlCol="0" anchor="ctr"/>
+          <a:lstStyle/>
+          <a:p>
+            <a:pPr algn="ctr"/>
+          </a:p>
+        </p:txBody>
+      </p:sp>
+      <p:sp>
+        <p:nvSpPr>
+          <p:cNvPr id="25" name="TextBox 24"/>
+          <p:cNvSpPr txBox="1"/>
+          <p:nvPr/>
+        </p:nvSpPr>
+        <p:spPr>
+          <a:xfrm>
+            <a:off x="6598767" y="4681728"/>
+            <a:ext cx="4523079" cy="868680"/>
+          </a:xfrm>
+          <a:prstGeom prst="rect">
+            <a:avLst/>
+          </a:prstGeom>
+          <a:noFill/>
+        </p:spPr>
+        <p:txBody>
+          <a:bodyPr wrap="square" lIns="0" rIns="0" tIns="0" bIns="0">
+            <a:spAutoFit/>
+          </a:bodyPr>
+          <a:lstStyle/>
+          <a:p>
+            <a:pPr algn="l">
+              <a:spcBef>
+                <a:spcPts val="0"/>
+              </a:spcBef>
+              <a:spcAft>
+                <a:spcPts val="600"/>
+              </a:spcAft>
+            </a:pPr>
+            <a:r>
+              <a:rPr sz="1350" b="0" i="0">
+                <a:solidFill>
+                  <a:srgbClr val="2B2B2B"/>
+                </a:solidFill>
+                <a:latin typeface="Calibri"/>
+              </a:rPr>
+              <a:t>L2 (λ=0,05) calibrado empiricamente, não por cross-validation formal.</a:t>
+            </a:r>
+          </a:p>
+        </p:txBody>
+      </p:sp>
+    </p:spTree>
+  </p:cSld>
+  <p:clrMapOvr>
+    <a:masterClrMapping/>
+  </p:clrMapOvr>
+</p:sld>
+</file>
+
+<file path=ppt/slides/slide15.xml><?xml version="1.0" encoding="utf-8"?>
+<p:sld xmlns:a="http://schemas.openxmlformats.org/drawingml/2006/main" xmlns:p="http://schemas.openxmlformats.org/presentationml/2006/main" xmlns:r="http://schemas.openxmlformats.org/officeDocument/2006/relationships">
+  <p:cSld>
+    <p:spTree>
+      <p:nvGrpSpPr>
+        <p:cNvPr id="1" name=""/>
+        <p:cNvGrpSpPr/>
+        <p:nvPr/>
+      </p:nvGrpSpPr>
+      <p:grpSpPr/>
+      <p:sp>
+        <p:nvSpPr>
+          <p:cNvPr id="2" name="Rectangle 1"/>
+          <p:cNvSpPr/>
+          <p:nvPr/>
+        </p:nvSpPr>
+        <p:spPr>
+          <a:xfrm>
+            <a:off x="0" y="0"/>
+            <a:ext cx="12191695" cy="6858000"/>
+          </a:xfrm>
+          <a:prstGeom prst="rect">
+            <a:avLst/>
+          </a:prstGeom>
+          <a:solidFill>
+            <a:srgbClr val="FFFFFF"/>
+          </a:solidFill>
+          <a:ln>
+            <a:noFill/>
+          </a:ln>
+          <a:effectLst/>
+        </p:spPr>
+        <p:style>
+          <a:lnRef idx="1">
+            <a:schemeClr val="accent1"/>
+          </a:lnRef>
+          <a:fillRef idx="3">
+            <a:schemeClr val="accent1"/>
+          </a:fillRef>
+          <a:effectRef idx="2">
+            <a:schemeClr val="accent1"/>
+          </a:effectRef>
+          <a:fontRef idx="minor">
+            <a:schemeClr val="lt1"/>
+          </a:fontRef>
+        </p:style>
+        <p:txBody>
+          <a:bodyPr rtlCol="0" anchor="ctr"/>
+          <a:lstStyle/>
+          <a:p>
+            <a:pPr algn="ctr"/>
+          </a:p>
+        </p:txBody>
+      </p:sp>
+      <p:sp>
+        <p:nvSpPr>
+          <p:cNvPr id="3" name="TextBox 2"/>
+          <p:cNvSpPr txBox="1"/>
+          <p:nvPr/>
+        </p:nvSpPr>
+        <p:spPr>
+          <a:xfrm>
+            <a:off x="841248" y="411480"/>
+            <a:ext cx="10509199" cy="274320"/>
+          </a:xfrm>
+          <a:prstGeom prst="rect">
+            <a:avLst/>
+          </a:prstGeom>
+          <a:noFill/>
+        </p:spPr>
+        <p:txBody>
+          <a:bodyPr wrap="square" lIns="0" rIns="0" tIns="0" bIns="0">
+            <a:spAutoFit/>
+          </a:bodyPr>
+          <a:lstStyle/>
+          <a:p>
+            <a:pPr algn="l">
+              <a:spcBef>
+                <a:spcPts val="0"/>
+              </a:spcBef>
+              <a:spcAft>
+                <a:spcPts val="0"/>
+              </a:spcAft>
+            </a:pPr>
+            <a:r>
+              <a:rPr sz="1100" b="1" i="0">
+                <a:solidFill>
+                  <a:srgbClr val="3C7A8C"/>
+                </a:solidFill>
+                <a:latin typeface="Calibri"/>
+              </a:rPr>
+              <a:t>FECHAMENTO</a:t>
+            </a:r>
+          </a:p>
+        </p:txBody>
+      </p:sp>
+      <p:sp>
+        <p:nvSpPr>
+          <p:cNvPr id="4" name="TextBox 3"/>
+          <p:cNvSpPr txBox="1"/>
+          <p:nvPr/>
+        </p:nvSpPr>
+        <p:spPr>
+          <a:xfrm>
+            <a:off x="841248" y="676656"/>
+            <a:ext cx="10509199" cy="640080"/>
+          </a:xfrm>
+          <a:prstGeom prst="rect">
+            <a:avLst/>
+          </a:prstGeom>
+          <a:noFill/>
+        </p:spPr>
+        <p:txBody>
+          <a:bodyPr wrap="square" lIns="0" rIns="0" tIns="0" bIns="0">
+            <a:spAutoFit/>
+          </a:bodyPr>
+          <a:lstStyle/>
+          <a:p>
+            <a:pPr algn="l">
+              <a:spcBef>
+                <a:spcPts val="0"/>
+              </a:spcBef>
+              <a:spcAft>
+                <a:spcPts val="0"/>
+              </a:spcAft>
+            </a:pPr>
+            <a:r>
+              <a:rPr sz="2700" b="1" i="0">
+                <a:solidFill>
+                  <a:srgbClr val="2B2B2B"/>
+                </a:solidFill>
+                <a:latin typeface="Cambria"/>
+              </a:rPr>
+              <a:t>Próximos passos e conclusão</a:t>
+            </a:r>
+          </a:p>
+        </p:txBody>
+      </p:sp>
+      <p:sp>
+        <p:nvSpPr>
+          <p:cNvPr id="5" name="Rectangle 4"/>
+          <p:cNvSpPr/>
+          <p:nvPr/>
+        </p:nvSpPr>
+        <p:spPr>
+          <a:xfrm>
+            <a:off x="841248" y="1380363"/>
+            <a:ext cx="10509199" cy="19050"/>
+          </a:xfrm>
+          <a:prstGeom prst="rect">
+            <a:avLst/>
+          </a:prstGeom>
+          <a:solidFill>
+            <a:srgbClr val="1F4E5F"/>
+          </a:solidFill>
+          <a:ln>
+            <a:noFill/>
+          </a:ln>
+          <a:effectLst/>
+        </p:spPr>
+        <p:style>
+          <a:lnRef idx="1">
+            <a:schemeClr val="accent1"/>
+          </a:lnRef>
+          <a:fillRef idx="3">
+            <a:schemeClr val="accent1"/>
+          </a:fillRef>
+          <a:effectRef idx="2">
+            <a:schemeClr val="accent1"/>
+          </a:effectRef>
+          <a:fontRef idx="minor">
+            <a:schemeClr val="lt1"/>
+          </a:fontRef>
+        </p:style>
+        <p:txBody>
+          <a:bodyPr rtlCol="0" anchor="ctr"/>
+          <a:lstStyle/>
+          <a:p>
+            <a:pPr algn="ctr"/>
+          </a:p>
+        </p:txBody>
+      </p:sp>
+      <p:sp>
+        <p:nvSpPr>
+          <p:cNvPr id="6" name="TextBox 5"/>
+          <p:cNvSpPr txBox="1"/>
+          <p:nvPr/>
+        </p:nvSpPr>
+        <p:spPr>
+          <a:xfrm>
+            <a:off x="841248" y="6400800"/>
+            <a:ext cx="7315200" cy="274320"/>
+          </a:xfrm>
+          <a:prstGeom prst="rect">
+            <a:avLst/>
+          </a:prstGeom>
+          <a:noFill/>
+        </p:spPr>
+        <p:txBody>
+          <a:bodyPr wrap="square" lIns="0" rIns="0" tIns="0" bIns="0">
+            <a:spAutoFit/>
+          </a:bodyPr>
+          <a:lstStyle/>
+          <a:p>
+            <a:pPr algn="l">
+              <a:spcBef>
+                <a:spcPts val="0"/>
+              </a:spcBef>
+              <a:spcAft>
+                <a:spcPts val="0"/>
+              </a:spcAft>
+            </a:pPr>
+            <a:r>
+              <a:rPr sz="900" b="0" i="0">
+                <a:solidFill>
+                  <a:srgbClr val="6B7276"/>
+                </a:solidFill>
+                <a:latin typeface="Calibri"/>
+              </a:rPr>
+              <a:t>Projeto REDS-DM1  ·  Equipe 4  ·  Computação Natural</a:t>
+            </a:r>
+          </a:p>
+        </p:txBody>
+      </p:sp>
+      <p:sp>
+        <p:nvSpPr>
+          <p:cNvPr id="7" name="TextBox 6"/>
+          <p:cNvSpPr txBox="1"/>
+          <p:nvPr/>
+        </p:nvSpPr>
+        <p:spPr>
+          <a:xfrm>
+            <a:off x="10545775" y="6400800"/>
+            <a:ext cx="804672" cy="274320"/>
+          </a:xfrm>
+          <a:prstGeom prst="rect">
+            <a:avLst/>
+          </a:prstGeom>
+          <a:noFill/>
+        </p:spPr>
+        <p:txBody>
+          <a:bodyPr wrap="square" lIns="0" rIns="0" tIns="0" bIns="0">
+            <a:spAutoFit/>
+          </a:bodyPr>
+          <a:lstStyle/>
+          <a:p>
+            <a:pPr algn="r">
+              <a:spcBef>
+                <a:spcPts val="0"/>
+              </a:spcBef>
+              <a:spcAft>
+                <a:spcPts val="0"/>
+              </a:spcAft>
+            </a:pPr>
+            <a:r>
+              <a:rPr sz="900" b="0" i="0">
+                <a:solidFill>
+                  <a:srgbClr val="6B7276"/>
+                </a:solidFill>
+                <a:latin typeface="Calibri"/>
+              </a:rPr>
+              <a:t>14 / 14</a:t>
             </a:r>
           </a:p>
         </p:txBody>
@@ -7780,7 +8908,7 @@
                 </a:solidFill>
                 <a:latin typeface="Calibri"/>
               </a:rPr>
-              <a:t>01 / 13</a:t>
+              <a:t>01 / 14</a:t>
             </a:r>
           </a:p>
         </p:txBody>
@@ -8931,7 +10059,7 @@
                 </a:solidFill>
                 <a:latin typeface="Calibri"/>
               </a:rPr>
-              <a:t>02 / 13</a:t>
+              <a:t>02 / 14</a:t>
             </a:r>
           </a:p>
         </p:txBody>
@@ -9851,7 +10979,7 @@
                 </a:solidFill>
                 <a:latin typeface="Calibri"/>
               </a:rPr>
-              <a:t>03 / 13</a:t>
+              <a:t>03 / 14</a:t>
             </a:r>
           </a:p>
         </p:txBody>
@@ -11075,7 +12203,7 @@
                 </a:solidFill>
                 <a:latin typeface="Calibri"/>
               </a:rPr>
-              <a:t>04 / 13</a:t>
+              <a:t>04 / 14</a:t>
             </a:r>
           </a:p>
         </p:txBody>
@@ -12875,7 +14003,7 @@
                 </a:solidFill>
                 <a:latin typeface="Calibri"/>
               </a:rPr>
-              <a:t>05 / 13</a:t>
+              <a:t>05 / 14</a:t>
             </a:r>
           </a:p>
         </p:txBody>
@@ -13767,7 +14895,7 @@
                 </a:solidFill>
                 <a:latin typeface="Calibri"/>
               </a:rPr>
-              <a:t>06 / 13</a:t>
+              <a:t>06 / 14</a:t>
             </a:r>
           </a:p>
         </p:txBody>
@@ -14749,7 +15877,7 @@
                 </a:solidFill>
                 <a:latin typeface="Calibri"/>
               </a:rPr>
-              <a:t>07 / 13</a:t>
+              <a:t>07 / 14</a:t>
             </a:r>
           </a:p>
         </p:txBody>
@@ -17324,7 +18452,7 @@
                 </a:solidFill>
                 <a:latin typeface="Calibri"/>
               </a:rPr>
-              <a:t>08 / 13</a:t>
+              <a:t>08 / 14</a:t>
             </a:r>
           </a:p>
         </p:txBody>

</xml_diff>